<commit_message>
Updated content, corrected slides, fixed typos and animmations
</commit_message>
<xml_diff>
--- a/LectureSlides/14_HierarchicalBayesModels.pptx
+++ b/LectureSlides/14_HierarchicalBayesModels.pptx
@@ -359,7 +359,7 @@
           <a:p>
             <a:fld id="{241EB5C9-1307-BA42-ABA2-0BC069CD8E7F}" type="datetimeFigureOut">
               <a:rPr lang="en-US" smtClean="0"/>
-              <a:t>10/28/2026</a:t>
+              <a:t>10/29/2026</a:t>
             </a:fld>
             <a:endParaRPr lang="en-US"/>
           </a:p>
@@ -527,7 +527,7 @@
           <a:p>
             <a:fld id="{241EB5C9-1307-BA42-ABA2-0BC069CD8E7F}" type="datetimeFigureOut">
               <a:rPr lang="en-US" smtClean="0"/>
-              <a:t>10/28/2026</a:t>
+              <a:t>10/29/2026</a:t>
             </a:fld>
             <a:endParaRPr lang="en-US"/>
           </a:p>
@@ -705,7 +705,7 @@
           <a:p>
             <a:fld id="{241EB5C9-1307-BA42-ABA2-0BC069CD8E7F}" type="datetimeFigureOut">
               <a:rPr lang="en-US" smtClean="0"/>
-              <a:t>10/28/2026</a:t>
+              <a:t>10/29/2026</a:t>
             </a:fld>
             <a:endParaRPr lang="en-US"/>
           </a:p>
@@ -873,7 +873,7 @@
           <a:p>
             <a:fld id="{241EB5C9-1307-BA42-ABA2-0BC069CD8E7F}" type="datetimeFigureOut">
               <a:rPr lang="en-US" smtClean="0"/>
-              <a:t>10/28/2026</a:t>
+              <a:t>10/29/2026</a:t>
             </a:fld>
             <a:endParaRPr lang="en-US"/>
           </a:p>
@@ -1118,7 +1118,7 @@
           <a:p>
             <a:fld id="{241EB5C9-1307-BA42-ABA2-0BC069CD8E7F}" type="datetimeFigureOut">
               <a:rPr lang="en-US" smtClean="0"/>
-              <a:t>10/28/2026</a:t>
+              <a:t>10/29/2026</a:t>
             </a:fld>
             <a:endParaRPr lang="en-US"/>
           </a:p>
@@ -1403,7 +1403,7 @@
           <a:p>
             <a:fld id="{241EB5C9-1307-BA42-ABA2-0BC069CD8E7F}" type="datetimeFigureOut">
               <a:rPr lang="en-US" smtClean="0"/>
-              <a:t>10/28/2026</a:t>
+              <a:t>10/29/2026</a:t>
             </a:fld>
             <a:endParaRPr lang="en-US"/>
           </a:p>
@@ -1822,7 +1822,7 @@
           <a:p>
             <a:fld id="{241EB5C9-1307-BA42-ABA2-0BC069CD8E7F}" type="datetimeFigureOut">
               <a:rPr lang="en-US" smtClean="0"/>
-              <a:t>10/28/2026</a:t>
+              <a:t>10/29/2026</a:t>
             </a:fld>
             <a:endParaRPr lang="en-US"/>
           </a:p>
@@ -1939,7 +1939,7 @@
           <a:p>
             <a:fld id="{241EB5C9-1307-BA42-ABA2-0BC069CD8E7F}" type="datetimeFigureOut">
               <a:rPr lang="en-US" smtClean="0"/>
-              <a:t>10/28/2026</a:t>
+              <a:t>10/29/2026</a:t>
             </a:fld>
             <a:endParaRPr lang="en-US"/>
           </a:p>
@@ -2034,7 +2034,7 @@
           <a:p>
             <a:fld id="{241EB5C9-1307-BA42-ABA2-0BC069CD8E7F}" type="datetimeFigureOut">
               <a:rPr lang="en-US" smtClean="0"/>
-              <a:t>10/28/2026</a:t>
+              <a:t>10/29/2026</a:t>
             </a:fld>
             <a:endParaRPr lang="en-US"/>
           </a:p>
@@ -2309,7 +2309,7 @@
           <a:p>
             <a:fld id="{241EB5C9-1307-BA42-ABA2-0BC069CD8E7F}" type="datetimeFigureOut">
               <a:rPr lang="en-US" smtClean="0"/>
-              <a:t>10/28/2026</a:t>
+              <a:t>10/29/2026</a:t>
             </a:fld>
             <a:endParaRPr lang="en-US"/>
           </a:p>
@@ -2561,7 +2561,7 @@
           <a:p>
             <a:fld id="{241EB5C9-1307-BA42-ABA2-0BC069CD8E7F}" type="datetimeFigureOut">
               <a:rPr lang="en-US" smtClean="0"/>
-              <a:t>10/28/2026</a:t>
+              <a:t>10/29/2026</a:t>
             </a:fld>
             <a:endParaRPr lang="en-US"/>
           </a:p>
@@ -2772,7 +2772,7 @@
           <a:p>
             <a:fld id="{241EB5C9-1307-BA42-ABA2-0BC069CD8E7F}" type="datetimeFigureOut">
               <a:rPr lang="en-US" smtClean="0"/>
-              <a:t>10/28/2026</a:t>
+              <a:t>10/29/2026</a:t>
             </a:fld>
             <a:endParaRPr lang="en-US"/>
           </a:p>
@@ -3216,30 +3216,6 @@
           </a:p>
         </p:txBody>
       </p:sp>
-      <p:sp>
-        <p:nvSpPr>
-          <p:cNvPr id="4" name="Date Placeholder 3"/>
-          <p:cNvSpPr>
-            <a:spLocks noGrp="1"/>
-          </p:cNvSpPr>
-          <p:nvPr>
-            <p:ph type="dt" sz="half" idx="10"/>
-          </p:nvPr>
-        </p:nvSpPr>
-        <p:spPr/>
-        <p:txBody>
-          <a:bodyPr/>
-          <a:lstStyle/>
-          <a:p>
-            <a:pPr marL="0" lvl="0" indent="0">
-              <a:buNone/>
-            </a:pPr>
-            <a:r>
-              <a:t>09/04/2023</a:t>
-            </a:r>
-          </a:p>
-        </p:txBody>
-      </p:sp>
       <p:pic>
         <p:nvPicPr>
           <p:cNvPr id="5" name="Picture 2" descr="Image result for harvard extension school logo">
@@ -3318,7 +3294,7 @@
             <a:pPr algn="ctr"/>
             <a:r>
               <a:rPr lang="en-US" sz="1100" dirty="0"/>
-              <a:t>Copyright, 2023 2024, 2025, Stephen F Elston. All rights reserved</a:t>
+              <a:t>Copyright, 2023 2024, 2025, 2026, Stephen F Elston. All rights reserved</a:t>
             </a:r>
             <a:r>
               <a:rPr lang="en-US" dirty="0"/>
@@ -7212,8 +7188,8 @@
           </a:p>
         </p:txBody>
       </p:sp>
-      <mc:AlternateContent xmlns:mc="http://schemas.openxmlformats.org/markup-compatibility/2006">
-        <mc:Choice xmlns:a14="http://schemas.microsoft.com/office/drawing/2010/main" Requires="a14">
+      <mc:AlternateContent xmlns:mc="http://schemas.openxmlformats.org/markup-compatibility/2006" xmlns:a14="http://schemas.microsoft.com/office/drawing/2010/main">
+        <mc:Choice Requires="a14">
           <p:sp>
             <p:nvSpPr>
               <p:cNvPr id="4" name="Text Placeholder 3"/>
@@ -7726,7 +7702,7 @@
             </p:txBody>
           </p:sp>
         </mc:Choice>
-        <mc:Fallback>
+        <mc:Fallback xmlns="">
           <p:sp>
             <p:nvSpPr>
               <p:cNvPr id="4" name="Text Placeholder 3"/>
@@ -9472,7 +9448,7 @@
                 </a:pPr>
                 <a:r>
                   <a:rPr lang="en-US" sz="2000" dirty="0"/>
-                  <a:t>Posterior predictive checks show good fit</a:t>
+                  <a:t>Posterior predictive checks show generally good fit</a:t>
                 </a:r>
               </a:p>
               <a:p>
@@ -9484,10 +9460,8 @@
               <a:p>
                 <a:r>
                   <a:rPr lang="en-US" sz="2000" dirty="0"/>
-                  <a:t>The Bayesian p-value shows significant deviations respect to the ideal distribution </a:t>
+                  <a:t>The </a:t>
                 </a:r>
-              </a:p>
-              <a:p>
                 <a14:m>
                   <m:oMath xmlns:m="http://schemas.openxmlformats.org/officeDocument/2006/math">
                     <m:r>
@@ -9508,7 +9482,13 @@
                 </a14:m>
                 <a:r>
                   <a:rPr lang="en-US" sz="2000" dirty="0"/>
-                  <a:t> distribution is skewed with respect to the observed   </a:t>
+                  <a:t> shows significant deviations respect to the ideal distribution </a:t>
+                </a:r>
+              </a:p>
+              <a:p>
+                <a:r>
+                  <a:rPr lang="en-US" sz="2000" dirty="0"/>
+                  <a:t>Sampled mean distribution is skewed with respect to the observed   </a:t>
                 </a:r>
               </a:p>
             </p:txBody>
@@ -9539,7 +9519,7 @@
               <a:blipFill>
                 <a:blip r:embed="rId2"/>
                 <a:stretch>
-                  <a:fillRect l="-1567" t="-940" r="-855"/>
+                  <a:fillRect l="-1567" t="-940"/>
                 </a:stretch>
               </a:blipFill>
             </p:spPr>
@@ -9644,6 +9624,33 @@
                                   </p:childTnLst>
                                 </p:cTn>
                               </p:par>
+                              <p:par>
+                                <p:cTn id="7" presetID="1" presetClass="entr" presetSubtype="0" fill="hold" nodeType="withEffect">
+                                  <p:stCondLst>
+                                    <p:cond delay="0"/>
+                                  </p:stCondLst>
+                                  <p:childTnLst>
+                                    <p:set>
+                                      <p:cBhvr>
+                                        <p:cTn id="8" dur="1" fill="hold">
+                                          <p:stCondLst>
+                                            <p:cond delay="0"/>
+                                          </p:stCondLst>
+                                        </p:cTn>
+                                        <p:tgtEl>
+                                          <p:spTgt spid="6"/>
+                                        </p:tgtEl>
+                                        <p:attrNameLst>
+                                          <p:attrName>style.visibility</p:attrName>
+                                        </p:attrNameLst>
+                                      </p:cBhvr>
+                                      <p:to>
+                                        <p:strVal val="visible"/>
+                                      </p:to>
+                                    </p:set>
+                                  </p:childTnLst>
+                                </p:cTn>
+                              </p:par>
                             </p:childTnLst>
                           </p:cTn>
                         </p:par>
@@ -9651,26 +9658,26 @@
                     </p:cTn>
                   </p:par>
                   <p:par>
-                    <p:cTn id="7" fill="hold">
+                    <p:cTn id="9" fill="hold">
                       <p:stCondLst>
                         <p:cond delay="indefinite"/>
                       </p:stCondLst>
                       <p:childTnLst>
                         <p:par>
-                          <p:cTn id="8" fill="hold">
+                          <p:cTn id="10" fill="hold">
                             <p:stCondLst>
                               <p:cond delay="0"/>
                             </p:stCondLst>
                             <p:childTnLst>
                               <p:par>
-                                <p:cTn id="9" presetID="1" presetClass="entr" presetSubtype="0" fill="hold" nodeType="clickEffect">
+                                <p:cTn id="11" presetID="1" presetClass="entr" presetSubtype="0" fill="hold" nodeType="clickEffect">
                                   <p:stCondLst>
                                     <p:cond delay="0"/>
                                   </p:stCondLst>
                                   <p:childTnLst>
                                     <p:set>
                                       <p:cBhvr>
-                                        <p:cTn id="10" dur="1" fill="hold">
+                                        <p:cTn id="12" dur="1" fill="hold">
                                           <p:stCondLst>
                                             <p:cond delay="0"/>
                                           </p:stCondLst>
@@ -9700,26 +9707,26 @@
                     </p:cTn>
                   </p:par>
                   <p:par>
-                    <p:cTn id="11" fill="hold">
+                    <p:cTn id="13" fill="hold">
                       <p:stCondLst>
                         <p:cond delay="indefinite"/>
                       </p:stCondLst>
                       <p:childTnLst>
                         <p:par>
-                          <p:cTn id="12" fill="hold">
+                          <p:cTn id="14" fill="hold">
                             <p:stCondLst>
                               <p:cond delay="0"/>
                             </p:stCondLst>
                             <p:childTnLst>
                               <p:par>
-                                <p:cTn id="13" presetID="1" presetClass="entr" presetSubtype="0" fill="hold" nodeType="clickEffect">
+                                <p:cTn id="15" presetID="1" presetClass="entr" presetSubtype="0" fill="hold" nodeType="clickEffect">
                                   <p:stCondLst>
                                     <p:cond delay="0"/>
                                   </p:stCondLst>
                                   <p:childTnLst>
                                     <p:set>
                                       <p:cBhvr>
-                                        <p:cTn id="14" dur="1" fill="hold">
+                                        <p:cTn id="16" dur="1" fill="hold">
                                           <p:stCondLst>
                                             <p:cond delay="0"/>
                                           </p:stCondLst>
@@ -11395,7 +11402,7 @@
                       <m:d>
                         <m:dPr>
                           <m:ctrlPr>
-                            <a:rPr lang="en-US" i="1">
+                            <a:rPr lang="en-US" b="0" i="1" smtClean="0">
                               <a:latin typeface="Cambria Math" panose="02040503050406030204" pitchFamily="18" charset="0"/>
                               <a:ea typeface="Cambria Math" panose="02040503050406030204" pitchFamily="18" charset="0"/>
                             </a:rPr>
@@ -15725,14 +15732,8 @@
                 </a:pPr>
                 <a:r>
                   <a:rPr lang="en-US" sz="2000" dirty="0"/>
-                  <a:t>The Bayesian p-value shows large bias with respect to the ideal distribution </a:t>
+                  <a:t>The </a:t>
                 </a:r>
-              </a:p>
-              <a:p>
-                <a:pPr>
-                  <a:buFont typeface="Arial" panose="020B0604020202020204" pitchFamily="34" charset="0"/>
-                  <a:buChar char="•"/>
-                </a:pPr>
                 <a14:m>
                   <m:oMath xmlns:m="http://schemas.openxmlformats.org/officeDocument/2006/math">
                     <m:r>
@@ -15753,7 +15754,17 @@
                 </a14:m>
                 <a:r>
                   <a:rPr lang="en-US" sz="2000" dirty="0"/>
-                  <a:t> distribution shows minimal with respect to the observed   </a:t>
+                  <a:t> shows large bias with respect to the ideal distribution </a:t>
+                </a:r>
+              </a:p>
+              <a:p>
+                <a:pPr>
+                  <a:buFont typeface="Arial" panose="020B0604020202020204" pitchFamily="34" charset="0"/>
+                  <a:buChar char="•"/>
+                </a:pPr>
+                <a:r>
+                  <a:rPr lang="en-US" sz="2000" dirty="0"/>
+                  <a:t>Sampled mean distribution shows minimal with respect to the observed   </a:t>
                 </a:r>
               </a:p>
             </p:txBody>
@@ -15785,7 +15796,7 @@
               <a:blipFill>
                 <a:blip r:embed="rId2"/>
                 <a:stretch>
-                  <a:fillRect l="-1220" t="-982" r="-2168"/>
+                  <a:fillRect l="-1220" t="-982" r="-2846"/>
                 </a:stretch>
               </a:blipFill>
             </p:spPr>
@@ -15895,6 +15906,33 @@
                                   </p:childTnLst>
                                 </p:cTn>
                               </p:par>
+                              <p:par>
+                                <p:cTn id="7" presetID="1" presetClass="entr" presetSubtype="0" fill="hold" nodeType="withEffect">
+                                  <p:stCondLst>
+                                    <p:cond delay="0"/>
+                                  </p:stCondLst>
+                                  <p:childTnLst>
+                                    <p:set>
+                                      <p:cBhvr>
+                                        <p:cTn id="8" dur="1" fill="hold">
+                                          <p:stCondLst>
+                                            <p:cond delay="0"/>
+                                          </p:stCondLst>
+                                        </p:cTn>
+                                        <p:tgtEl>
+                                          <p:spTgt spid="6"/>
+                                        </p:tgtEl>
+                                        <p:attrNameLst>
+                                          <p:attrName>style.visibility</p:attrName>
+                                        </p:attrNameLst>
+                                      </p:cBhvr>
+                                      <p:to>
+                                        <p:strVal val="visible"/>
+                                      </p:to>
+                                    </p:set>
+                                  </p:childTnLst>
+                                </p:cTn>
+                              </p:par>
                             </p:childTnLst>
                           </p:cTn>
                         </p:par>
@@ -15902,26 +15940,26 @@
                     </p:cTn>
                   </p:par>
                   <p:par>
-                    <p:cTn id="7" fill="hold">
+                    <p:cTn id="9" fill="hold">
                       <p:stCondLst>
                         <p:cond delay="indefinite"/>
                       </p:stCondLst>
                       <p:childTnLst>
                         <p:par>
-                          <p:cTn id="8" fill="hold">
+                          <p:cTn id="10" fill="hold">
                             <p:stCondLst>
                               <p:cond delay="0"/>
                             </p:stCondLst>
                             <p:childTnLst>
                               <p:par>
-                                <p:cTn id="9" presetID="1" presetClass="entr" presetSubtype="0" fill="hold" nodeType="clickEffect">
+                                <p:cTn id="11" presetID="1" presetClass="entr" presetSubtype="0" fill="hold" nodeType="clickEffect">
                                   <p:stCondLst>
                                     <p:cond delay="0"/>
                                   </p:stCondLst>
                                   <p:childTnLst>
                                     <p:set>
                                       <p:cBhvr>
-                                        <p:cTn id="10" dur="1" fill="hold">
+                                        <p:cTn id="12" dur="1" fill="hold">
                                           <p:stCondLst>
                                             <p:cond delay="0"/>
                                           </p:stCondLst>
@@ -15951,26 +15989,26 @@
                     </p:cTn>
                   </p:par>
                   <p:par>
-                    <p:cTn id="11" fill="hold">
+                    <p:cTn id="13" fill="hold">
                       <p:stCondLst>
                         <p:cond delay="indefinite"/>
                       </p:stCondLst>
                       <p:childTnLst>
                         <p:par>
-                          <p:cTn id="12" fill="hold">
+                          <p:cTn id="14" fill="hold">
                             <p:stCondLst>
                               <p:cond delay="0"/>
                             </p:stCondLst>
                             <p:childTnLst>
                               <p:par>
-                                <p:cTn id="13" presetID="1" presetClass="entr" presetSubtype="0" fill="hold" nodeType="clickEffect">
+                                <p:cTn id="15" presetID="1" presetClass="entr" presetSubtype="0" fill="hold" nodeType="clickEffect">
                                   <p:stCondLst>
                                     <p:cond delay="0"/>
                                   </p:stCondLst>
                                   <p:childTnLst>
                                     <p:set>
                                       <p:cBhvr>
-                                        <p:cTn id="14" dur="1" fill="hold">
+                                        <p:cTn id="16" dur="1" fill="hold">
                                           <p:stCondLst>
                                             <p:cond delay="0"/>
                                           </p:stCondLst>
@@ -16180,7 +16218,7 @@
         </p:spPr>
         <p:txBody>
           <a:bodyPr>
-            <a:normAutofit fontScale="92500" lnSpcReduction="20000"/>
+            <a:normAutofit fontScale="92500" lnSpcReduction="10000"/>
           </a:bodyPr>
           <a:lstStyle/>
           <a:p>
@@ -16273,21 +16311,6 @@
             <a:pPr lvl="0"/>
             <a:r>
               <a:rPr lang="en-US" dirty="0"/>
-              <a:t>Observations are </a:t>
-            </a:r>
-            <a:r>
-              <a:rPr lang="en-US" dirty="0" err="1"/>
-              <a:t>iid</a:t>
-            </a:r>
-            <a:r>
-              <a:rPr lang="en-US" dirty="0"/>
-              <a:t> within each county </a:t>
-            </a:r>
-          </a:p>
-          <a:p>
-            <a:pPr lvl="0"/>
-            <a:r>
-              <a:rPr lang="en-US" dirty="0"/>
               <a:t>We assume the observations </a:t>
             </a:r>
             <a:r>
@@ -16316,6 +16339,22 @@
               <a:rPr lang="en-US" b="1" dirty="0"/>
               <a:t>not between counties</a:t>
             </a:r>
+          </a:p>
+          <a:p>
+            <a:pPr lvl="1"/>
+            <a:r>
+              <a:rPr lang="en-US" dirty="0"/>
+              <a:t>Assumes observations are </a:t>
+            </a:r>
+            <a:r>
+              <a:rPr lang="en-US" dirty="0" err="1"/>
+              <a:t>iid</a:t>
+            </a:r>
+            <a:r>
+              <a:rPr lang="en-US" dirty="0"/>
+              <a:t> within each county </a:t>
+            </a:r>
+            <a:endParaRPr lang="en-US" b="1" dirty="0"/>
           </a:p>
           <a:p>
             <a:pPr lvl="0"/>
@@ -16578,33 +16617,15 @@
                                   </p:childTnLst>
                                 </p:cTn>
                               </p:par>
-                            </p:childTnLst>
-                          </p:cTn>
-                        </p:par>
-                      </p:childTnLst>
-                    </p:cTn>
-                  </p:par>
-                  <p:par>
-                    <p:cTn id="21" fill="hold">
-                      <p:stCondLst>
-                        <p:cond delay="indefinite"/>
-                      </p:stCondLst>
-                      <p:childTnLst>
-                        <p:par>
-                          <p:cTn id="22" fill="hold">
-                            <p:stCondLst>
-                              <p:cond delay="0"/>
-                            </p:stCondLst>
-                            <p:childTnLst>
                               <p:par>
-                                <p:cTn id="23" presetID="1" presetClass="entr" presetSubtype="0" fill="hold" nodeType="clickEffect">
+                                <p:cTn id="21" presetID="1" presetClass="entr" presetSubtype="0" fill="hold" nodeType="withEffect">
                                   <p:stCondLst>
                                     <p:cond delay="0"/>
                                   </p:stCondLst>
                                   <p:childTnLst>
                                     <p:set>
                                       <p:cBhvr>
-                                        <p:cTn id="24" dur="1" fill="hold">
+                                        <p:cTn id="22" dur="1" fill="hold">
                                           <p:stCondLst>
                                             <p:cond delay="0"/>
                                           </p:stCondLst>
@@ -16634,26 +16655,26 @@
                     </p:cTn>
                   </p:par>
                   <p:par>
-                    <p:cTn id="25" fill="hold">
+                    <p:cTn id="23" fill="hold">
                       <p:stCondLst>
                         <p:cond delay="indefinite"/>
                       </p:stCondLst>
                       <p:childTnLst>
                         <p:par>
-                          <p:cTn id="26" fill="hold">
+                          <p:cTn id="24" fill="hold">
                             <p:stCondLst>
                               <p:cond delay="0"/>
                             </p:stCondLst>
                             <p:childTnLst>
                               <p:par>
-                                <p:cTn id="27" presetID="1" presetClass="entr" presetSubtype="0" fill="hold" nodeType="clickEffect">
+                                <p:cTn id="25" presetID="1" presetClass="entr" presetSubtype="0" fill="hold" nodeType="clickEffect">
                                   <p:stCondLst>
                                     <p:cond delay="0"/>
                                   </p:stCondLst>
                                   <p:childTnLst>
                                     <p:set>
                                       <p:cBhvr>
-                                        <p:cTn id="28" dur="1" fill="hold">
+                                        <p:cTn id="26" dur="1" fill="hold">
                                           <p:stCondLst>
                                             <p:cond delay="0"/>
                                           </p:stCondLst>
@@ -16772,8 +16793,8 @@
           </a:p>
         </p:txBody>
       </p:sp>
-      <mc:AlternateContent xmlns:mc="http://schemas.openxmlformats.org/markup-compatibility/2006" xmlns:a14="http://schemas.microsoft.com/office/drawing/2010/main">
-        <mc:Choice Requires="a14">
+      <mc:AlternateContent xmlns:mc="http://schemas.openxmlformats.org/markup-compatibility/2006">
+        <mc:Choice xmlns:a14="http://schemas.microsoft.com/office/drawing/2010/main" Requires="a14">
           <p:sp>
             <p:nvSpPr>
               <p:cNvPr id="4" name="Text Placeholder 3">
@@ -16817,8 +16838,12 @@
                   <a:buChar char="•"/>
                 </a:pPr>
                 <a:r>
+                  <a:rPr lang="en-US" sz="2000" b="1" dirty="0"/>
+                  <a:t>Pooled hyperparameters </a:t>
+                </a:r>
+                <a:r>
                   <a:rPr lang="en-US" sz="2000" dirty="0"/>
-                  <a:t>Pooled hyperparameters at top level </a:t>
+                  <a:t>at top level </a:t>
                 </a:r>
               </a:p>
               <a:p>
@@ -17037,8 +17062,12 @@
                   <a:buChar char="•"/>
                 </a:pPr>
                 <a:r>
+                  <a:rPr lang="en-US" sz="2000" b="1" dirty="0"/>
+                  <a:t>County specific priors </a:t>
+                </a:r>
+                <a:r>
                   <a:rPr lang="en-US" sz="2000" dirty="0"/>
-                  <a:t>County specific priors for </a:t>
+                  <a:t>for </a:t>
                 </a:r>
                 <a14:m>
                   <m:oMath xmlns:m="http://schemas.openxmlformats.org/officeDocument/2006/math">
@@ -17389,7 +17418,7 @@
             </p:txBody>
           </p:sp>
         </mc:Choice>
-        <mc:Fallback xmlns="">
+        <mc:Fallback>
           <p:sp>
             <p:nvSpPr>
               <p:cNvPr id="4" name="Text Placeholder 3">
@@ -17414,7 +17443,7 @@
               <a:blipFill>
                 <a:blip r:embed="rId2"/>
                 <a:stretch>
-                  <a:fillRect l="-1757" t="-734"/>
+                  <a:fillRect l="-1757" t="-734" r="-1230"/>
                 </a:stretch>
               </a:blipFill>
             </p:spPr>
@@ -18218,10 +18247,10 @@
       </mc:AlternateContent>
       <p:pic>
         <p:nvPicPr>
-          <p:cNvPr id="3" name="Picture 2">
+          <p:cNvPr id="5" name="Picture 4">
             <a:extLst>
               <a:ext uri="{FF2B5EF4-FFF2-40B4-BE49-F238E27FC236}">
-                <a16:creationId xmlns:a16="http://schemas.microsoft.com/office/drawing/2014/main" id="{644BA63D-5A13-5BC5-50EA-7563FB9C67EB}"/>
+                <a16:creationId xmlns:a16="http://schemas.microsoft.com/office/drawing/2014/main" id="{92EE56D9-69AF-F16B-0F3D-5BC76D2F4DA2}"/>
               </a:ext>
             </a:extLst>
           </p:cNvPr>
@@ -18231,7 +18260,7 @@
           <p:nvPr/>
         </p:nvPicPr>
         <p:blipFill>
-          <a:blip r:embed="rId2"/>
+          <a:blip r:embed="rId3"/>
           <a:stretch>
             <a:fillRect/>
           </a:stretch>
@@ -19520,6 +19549,214 @@
   <p:clrMapOvr>
     <a:masterClrMapping/>
   </p:clrMapOvr>
+  <p:timing>
+    <p:tnLst>
+      <p:par>
+        <p:cTn id="1" dur="indefinite" restart="never" nodeType="tmRoot">
+          <p:childTnLst>
+            <p:seq concurrent="1" nextAc="seek">
+              <p:cTn id="2" dur="indefinite" nodeType="mainSeq">
+                <p:childTnLst>
+                  <p:par>
+                    <p:cTn id="3" fill="hold">
+                      <p:stCondLst>
+                        <p:cond delay="indefinite"/>
+                      </p:stCondLst>
+                      <p:childTnLst>
+                        <p:par>
+                          <p:cTn id="4" fill="hold">
+                            <p:stCondLst>
+                              <p:cond delay="0"/>
+                            </p:stCondLst>
+                            <p:childTnLst>
+                              <p:par>
+                                <p:cTn id="5" presetID="1" presetClass="entr" presetSubtype="0" fill="hold" nodeType="clickEffect">
+                                  <p:stCondLst>
+                                    <p:cond delay="0"/>
+                                  </p:stCondLst>
+                                  <p:childTnLst>
+                                    <p:set>
+                                      <p:cBhvr>
+                                        <p:cTn id="6" dur="1" fill="hold">
+                                          <p:stCondLst>
+                                            <p:cond delay="0"/>
+                                          </p:stCondLst>
+                                        </p:cTn>
+                                        <p:tgtEl>
+                                          <p:spTgt spid="6">
+                                            <p:txEl>
+                                              <p:pRg st="0" end="0"/>
+                                            </p:txEl>
+                                          </p:spTgt>
+                                        </p:tgtEl>
+                                        <p:attrNameLst>
+                                          <p:attrName>style.visibility</p:attrName>
+                                        </p:attrNameLst>
+                                      </p:cBhvr>
+                                      <p:to>
+                                        <p:strVal val="visible"/>
+                                      </p:to>
+                                    </p:set>
+                                  </p:childTnLst>
+                                </p:cTn>
+                              </p:par>
+                              <p:par>
+                                <p:cTn id="7" presetID="1" presetClass="entr" presetSubtype="0" fill="hold" nodeType="withEffect">
+                                  <p:stCondLst>
+                                    <p:cond delay="0"/>
+                                  </p:stCondLst>
+                                  <p:childTnLst>
+                                    <p:set>
+                                      <p:cBhvr>
+                                        <p:cTn id="8" dur="1" fill="hold">
+                                          <p:stCondLst>
+                                            <p:cond delay="0"/>
+                                          </p:stCondLst>
+                                        </p:cTn>
+                                        <p:tgtEl>
+                                          <p:spTgt spid="6">
+                                            <p:txEl>
+                                              <p:pRg st="1" end="1"/>
+                                            </p:txEl>
+                                          </p:spTgt>
+                                        </p:tgtEl>
+                                        <p:attrNameLst>
+                                          <p:attrName>style.visibility</p:attrName>
+                                        </p:attrNameLst>
+                                      </p:cBhvr>
+                                      <p:to>
+                                        <p:strVal val="visible"/>
+                                      </p:to>
+                                    </p:set>
+                                  </p:childTnLst>
+                                </p:cTn>
+                              </p:par>
+                            </p:childTnLst>
+                          </p:cTn>
+                        </p:par>
+                      </p:childTnLst>
+                    </p:cTn>
+                  </p:par>
+                  <p:par>
+                    <p:cTn id="9" fill="hold">
+                      <p:stCondLst>
+                        <p:cond delay="indefinite"/>
+                      </p:stCondLst>
+                      <p:childTnLst>
+                        <p:par>
+                          <p:cTn id="10" fill="hold">
+                            <p:stCondLst>
+                              <p:cond delay="0"/>
+                            </p:stCondLst>
+                            <p:childTnLst>
+                              <p:par>
+                                <p:cTn id="11" presetID="1" presetClass="entr" presetSubtype="0" fill="hold" nodeType="clickEffect">
+                                  <p:stCondLst>
+                                    <p:cond delay="0"/>
+                                  </p:stCondLst>
+                                  <p:childTnLst>
+                                    <p:set>
+                                      <p:cBhvr>
+                                        <p:cTn id="12" dur="1" fill="hold">
+                                          <p:stCondLst>
+                                            <p:cond delay="0"/>
+                                          </p:stCondLst>
+                                        </p:cTn>
+                                        <p:tgtEl>
+                                          <p:spTgt spid="6">
+                                            <p:txEl>
+                                              <p:pRg st="2" end="2"/>
+                                            </p:txEl>
+                                          </p:spTgt>
+                                        </p:tgtEl>
+                                        <p:attrNameLst>
+                                          <p:attrName>style.visibility</p:attrName>
+                                        </p:attrNameLst>
+                                      </p:cBhvr>
+                                      <p:to>
+                                        <p:strVal val="visible"/>
+                                      </p:to>
+                                    </p:set>
+                                  </p:childTnLst>
+                                </p:cTn>
+                              </p:par>
+                            </p:childTnLst>
+                          </p:cTn>
+                        </p:par>
+                      </p:childTnLst>
+                    </p:cTn>
+                  </p:par>
+                  <p:par>
+                    <p:cTn id="13" fill="hold">
+                      <p:stCondLst>
+                        <p:cond delay="indefinite"/>
+                      </p:stCondLst>
+                      <p:childTnLst>
+                        <p:par>
+                          <p:cTn id="14" fill="hold">
+                            <p:stCondLst>
+                              <p:cond delay="0"/>
+                            </p:stCondLst>
+                            <p:childTnLst>
+                              <p:par>
+                                <p:cTn id="15" presetID="1" presetClass="entr" presetSubtype="0" fill="hold" nodeType="clickEffect">
+                                  <p:stCondLst>
+                                    <p:cond delay="0"/>
+                                  </p:stCondLst>
+                                  <p:childTnLst>
+                                    <p:set>
+                                      <p:cBhvr>
+                                        <p:cTn id="16" dur="1" fill="hold">
+                                          <p:stCondLst>
+                                            <p:cond delay="0"/>
+                                          </p:stCondLst>
+                                        </p:cTn>
+                                        <p:tgtEl>
+                                          <p:spTgt spid="6">
+                                            <p:txEl>
+                                              <p:pRg st="3" end="3"/>
+                                            </p:txEl>
+                                          </p:spTgt>
+                                        </p:tgtEl>
+                                        <p:attrNameLst>
+                                          <p:attrName>style.visibility</p:attrName>
+                                        </p:attrNameLst>
+                                      </p:cBhvr>
+                                      <p:to>
+                                        <p:strVal val="visible"/>
+                                      </p:to>
+                                    </p:set>
+                                  </p:childTnLst>
+                                </p:cTn>
+                              </p:par>
+                            </p:childTnLst>
+                          </p:cTn>
+                        </p:par>
+                      </p:childTnLst>
+                    </p:cTn>
+                  </p:par>
+                </p:childTnLst>
+              </p:cTn>
+              <p:prevCondLst>
+                <p:cond evt="onPrev" delay="0">
+                  <p:tgtEl>
+                    <p:sldTgt/>
+                  </p:tgtEl>
+                </p:cond>
+              </p:prevCondLst>
+              <p:nextCondLst>
+                <p:cond evt="onNext" delay="0">
+                  <p:tgtEl>
+                    <p:sldTgt/>
+                  </p:tgtEl>
+                </p:cond>
+              </p:nextCondLst>
+            </p:seq>
+          </p:childTnLst>
+        </p:cTn>
+      </p:par>
+    </p:tnLst>
+  </p:timing>
 </p:sld>
 </file>
 
@@ -20737,9 +20974,16 @@
             <p:ph idx="1"/>
           </p:nvPr>
         </p:nvSpPr>
-        <p:spPr/>
+        <p:spPr>
+          <a:xfrm>
+            <a:off x="457200" y="1200151"/>
+            <a:ext cx="8229600" cy="3737370"/>
+          </a:xfrm>
+        </p:spPr>
         <p:txBody>
-          <a:bodyPr/>
+          <a:bodyPr>
+            <a:normAutofit fontScale="92500"/>
+          </a:bodyPr>
           <a:lstStyle/>
           <a:p>
             <a:pPr marL="0" lvl="0" indent="0">
@@ -20763,21 +21007,18 @@
             <a:pPr lvl="0"/>
             <a:r>
               <a:rPr dirty="0"/>
-              <a:t>Pooled model has a flat structure</a:t>
+              <a:t>Pooled model has a </a:t>
+            </a:r>
+            <a:r>
+              <a:rPr b="1" dirty="0"/>
+              <a:t>flat structure</a:t>
             </a:r>
           </a:p>
           <a:p>
-            <a:pPr lvl="0"/>
+            <a:pPr lvl="1"/>
             <a:r>
               <a:rPr dirty="0"/>
               <a:t>Model coefficients are at the same level</a:t>
-            </a:r>
-          </a:p>
-          <a:p>
-            <a:pPr lvl="0"/>
-            <a:r>
-              <a:rPr dirty="0"/>
-              <a:t>Pooling maximizes statistical power using all available data to fit a model</a:t>
             </a:r>
             <a:endParaRPr lang="en-US" dirty="0"/>
           </a:p>
@@ -20785,6 +21026,21 @@
             <a:pPr lvl="1"/>
             <a:r>
               <a:rPr lang="en-US" dirty="0"/>
+              <a:t>The OLS and GLM models we have worked with are frequentist flat models</a:t>
+            </a:r>
+            <a:endParaRPr dirty="0"/>
+          </a:p>
+          <a:p>
+            <a:pPr lvl="0"/>
+            <a:r>
+              <a:rPr dirty="0"/>
+              <a:t>Pooling maximizes statistical power using all available data to fit a model</a:t>
+            </a:r>
+            <a:endParaRPr lang="en-US" dirty="0"/>
+          </a:p>
+          <a:p>
+            <a:r>
+              <a:rPr lang="en-US" dirty="0"/>
               <a:t>Assumes </a:t>
             </a:r>
             <a:r>
@@ -20795,7 +21051,22 @@
               <a:rPr lang="en-US" dirty="0"/>
               <a:t> of observations between cases</a:t>
             </a:r>
-            <a:endParaRPr dirty="0"/>
+          </a:p>
+          <a:p>
+            <a:pPr lvl="1"/>
+            <a:r>
+              <a:rPr lang="en-US" dirty="0"/>
+              <a:t>Exchangeability assumes </a:t>
+            </a:r>
+            <a:r>
+              <a:rPr lang="en-US" b="1" dirty="0"/>
+              <a:t>variables are all </a:t>
+            </a:r>
+            <a:r>
+              <a:rPr lang="en-US" b="1" dirty="0" err="1"/>
+              <a:t>iid</a:t>
+            </a:r>
+            <a:endParaRPr b="1" dirty="0"/>
           </a:p>
           <a:p>
             <a:pPr lvl="0"/>
@@ -20862,26 +21133,39 @@
                                   </p:childTnLst>
                                 </p:cTn>
                               </p:par>
-                            </p:childTnLst>
-                          </p:cTn>
-                        </p:par>
-                      </p:childTnLst>
-                    </p:cTn>
-                  </p:par>
-                  <p:par>
-                    <p:cTn id="7" fill="hold">
-                      <p:stCondLst>
-                        <p:cond delay="indefinite"/>
-                      </p:stCondLst>
-                      <p:childTnLst>
-                        <p:par>
-                          <p:cTn id="8" fill="hold">
-                            <p:stCondLst>
-                              <p:cond delay="0"/>
-                            </p:stCondLst>
-                            <p:childTnLst>
                               <p:par>
-                                <p:cTn id="9" presetID="1" presetClass="entr" presetSubtype="0" fill="hold" nodeType="clickEffect">
+                                <p:cTn id="7" presetID="1" presetClass="entr" presetSubtype="0" fill="hold" nodeType="withEffect">
+                                  <p:stCondLst>
+                                    <p:cond delay="0"/>
+                                  </p:stCondLst>
+                                  <p:childTnLst>
+                                    <p:set>
+                                      <p:cBhvr>
+                                        <p:cTn id="8" dur="1" fill="hold">
+                                          <p:stCondLst>
+                                            <p:cond delay="0"/>
+                                          </p:stCondLst>
+                                        </p:cTn>
+                                        <p:tgtEl>
+                                          <p:spTgt spid="3">
+                                            <p:txEl>
+                                              <p:pRg st="2" end="2"/>
+                                            </p:txEl>
+                                          </p:spTgt>
+                                        </p:tgtEl>
+                                        <p:attrNameLst>
+                                          <p:attrName>style.visibility</p:attrName>
+                                        </p:attrNameLst>
+                                      </p:cBhvr>
+                                      <p:to>
+                                        <p:strVal val="visible"/>
+                                      </p:to>
+                                    </p:set>
+                                  </p:childTnLst>
+                                </p:cTn>
+                              </p:par>
+                              <p:par>
+                                <p:cTn id="9" presetID="1" presetClass="entr" presetSubtype="0" fill="hold" nodeType="withEffect">
                                   <p:stCondLst>
                                     <p:cond delay="0"/>
                                   </p:stCondLst>
@@ -20896,7 +21180,7 @@
                                         <p:tgtEl>
                                           <p:spTgt spid="3">
                                             <p:txEl>
-                                              <p:pRg st="2" end="2"/>
+                                              <p:pRg st="3" end="3"/>
                                             </p:txEl>
                                           </p:spTgt>
                                         </p:tgtEl>
@@ -20945,37 +21229,6 @@
                                         <p:tgtEl>
                                           <p:spTgt spid="3">
                                             <p:txEl>
-                                              <p:pRg st="3" end="3"/>
-                                            </p:txEl>
-                                          </p:spTgt>
-                                        </p:tgtEl>
-                                        <p:attrNameLst>
-                                          <p:attrName>style.visibility</p:attrName>
-                                        </p:attrNameLst>
-                                      </p:cBhvr>
-                                      <p:to>
-                                        <p:strVal val="visible"/>
-                                      </p:to>
-                                    </p:set>
-                                  </p:childTnLst>
-                                </p:cTn>
-                              </p:par>
-                              <p:par>
-                                <p:cTn id="15" presetID="1" presetClass="entr" presetSubtype="0" fill="hold" nodeType="withEffect">
-                                  <p:stCondLst>
-                                    <p:cond delay="0"/>
-                                  </p:stCondLst>
-                                  <p:childTnLst>
-                                    <p:set>
-                                      <p:cBhvr>
-                                        <p:cTn id="16" dur="1" fill="hold">
-                                          <p:stCondLst>
-                                            <p:cond delay="0"/>
-                                          </p:stCondLst>
-                                        </p:cTn>
-                                        <p:tgtEl>
-                                          <p:spTgt spid="3">
-                                            <p:txEl>
                                               <p:pRg st="4" end="4"/>
                                             </p:txEl>
                                           </p:spTgt>
@@ -20998,26 +21251,26 @@
                     </p:cTn>
                   </p:par>
                   <p:par>
-                    <p:cTn id="17" fill="hold">
+                    <p:cTn id="15" fill="hold">
                       <p:stCondLst>
                         <p:cond delay="indefinite"/>
                       </p:stCondLst>
                       <p:childTnLst>
                         <p:par>
-                          <p:cTn id="18" fill="hold">
+                          <p:cTn id="16" fill="hold">
                             <p:stCondLst>
                               <p:cond delay="0"/>
                             </p:stCondLst>
                             <p:childTnLst>
                               <p:par>
-                                <p:cTn id="19" presetID="1" presetClass="entr" presetSubtype="0" fill="hold" nodeType="clickEffect">
+                                <p:cTn id="17" presetID="1" presetClass="entr" presetSubtype="0" fill="hold" nodeType="clickEffect">
                                   <p:stCondLst>
                                     <p:cond delay="0"/>
                                   </p:stCondLst>
                                   <p:childTnLst>
                                     <p:set>
                                       <p:cBhvr>
-                                        <p:cTn id="20" dur="1" fill="hold">
+                                        <p:cTn id="18" dur="1" fill="hold">
                                           <p:stCondLst>
                                             <p:cond delay="0"/>
                                           </p:stCondLst>
@@ -21026,6 +21279,104 @@
                                           <p:spTgt spid="3">
                                             <p:txEl>
                                               <p:pRg st="5" end="5"/>
+                                            </p:txEl>
+                                          </p:spTgt>
+                                        </p:tgtEl>
+                                        <p:attrNameLst>
+                                          <p:attrName>style.visibility</p:attrName>
+                                        </p:attrNameLst>
+                                      </p:cBhvr>
+                                      <p:to>
+                                        <p:strVal val="visible"/>
+                                      </p:to>
+                                    </p:set>
+                                  </p:childTnLst>
+                                </p:cTn>
+                              </p:par>
+                            </p:childTnLst>
+                          </p:cTn>
+                        </p:par>
+                      </p:childTnLst>
+                    </p:cTn>
+                  </p:par>
+                  <p:par>
+                    <p:cTn id="19" fill="hold">
+                      <p:stCondLst>
+                        <p:cond delay="indefinite"/>
+                      </p:stCondLst>
+                      <p:childTnLst>
+                        <p:par>
+                          <p:cTn id="20" fill="hold">
+                            <p:stCondLst>
+                              <p:cond delay="0"/>
+                            </p:stCondLst>
+                            <p:childTnLst>
+                              <p:par>
+                                <p:cTn id="21" presetID="1" presetClass="entr" presetSubtype="0" fill="hold" nodeType="clickEffect">
+                                  <p:stCondLst>
+                                    <p:cond delay="0"/>
+                                  </p:stCondLst>
+                                  <p:childTnLst>
+                                    <p:set>
+                                      <p:cBhvr>
+                                        <p:cTn id="22" dur="1" fill="hold">
+                                          <p:stCondLst>
+                                            <p:cond delay="0"/>
+                                          </p:stCondLst>
+                                        </p:cTn>
+                                        <p:tgtEl>
+                                          <p:spTgt spid="3">
+                                            <p:txEl>
+                                              <p:pRg st="6" end="6"/>
+                                            </p:txEl>
+                                          </p:spTgt>
+                                        </p:tgtEl>
+                                        <p:attrNameLst>
+                                          <p:attrName>style.visibility</p:attrName>
+                                        </p:attrNameLst>
+                                      </p:cBhvr>
+                                      <p:to>
+                                        <p:strVal val="visible"/>
+                                      </p:to>
+                                    </p:set>
+                                  </p:childTnLst>
+                                </p:cTn>
+                              </p:par>
+                            </p:childTnLst>
+                          </p:cTn>
+                        </p:par>
+                      </p:childTnLst>
+                    </p:cTn>
+                  </p:par>
+                  <p:par>
+                    <p:cTn id="23" fill="hold">
+                      <p:stCondLst>
+                        <p:cond delay="indefinite"/>
+                      </p:stCondLst>
+                      <p:childTnLst>
+                        <p:par>
+                          <p:cTn id="24" fill="hold">
+                            <p:stCondLst>
+                              <p:cond delay="0"/>
+                            </p:stCondLst>
+                            <p:childTnLst>
+                              <p:par>
+                                <p:cTn id="25" presetID="1" presetClass="entr" presetSubtype="0" fill="hold" nodeType="clickEffect">
+                                  <p:stCondLst>
+                                    <p:cond delay="0"/>
+                                  </p:stCondLst>
+                                  <p:childTnLst>
+                                    <p:set>
+                                      <p:cBhvr>
+                                        <p:cTn id="26" dur="1" fill="hold">
+                                          <p:stCondLst>
+                                            <p:cond delay="0"/>
+                                          </p:stCondLst>
+                                        </p:cTn>
+                                        <p:tgtEl>
+                                          <p:spTgt spid="3">
+                                            <p:txEl>
+                                              <p:pRg st="7" end="7"/>
                                             </p:txEl>
                                           </p:spTgt>
                                         </p:tgtEl>
@@ -21946,7 +22297,7 @@
                 </a:pPr>
                 <a:r>
                   <a:rPr lang="en-US" dirty="0"/>
-                  <a:t>Posterior predictive checks show the update hieratical model is a good fit</a:t>
+                  <a:t>Posterior predictive checks show the update hieratical model is a generally good fit</a:t>
                 </a:r>
               </a:p>
               <a:p>
@@ -21966,14 +22317,8 @@
                 </a:pPr>
                 <a:r>
                   <a:rPr lang="en-US" dirty="0"/>
-                  <a:t>The Bayesian p-value some systematic bias with respect to the ideal distribution </a:t>
+                  <a:t>The </a:t>
                 </a:r>
-              </a:p>
-              <a:p>
-                <a:pPr>
-                  <a:buFont typeface="Arial" panose="020B0604020202020204" pitchFamily="34" charset="0"/>
-                  <a:buChar char="•"/>
-                </a:pPr>
                 <a14:m>
                   <m:oMath xmlns:m="http://schemas.openxmlformats.org/officeDocument/2006/math">
                     <m:r>
@@ -21994,7 +22339,17 @@
                 </a14:m>
                 <a:r>
                   <a:rPr lang="en-US" dirty="0"/>
-                  <a:t> distribution is skewed with respect to the observed   </a:t>
+                  <a:t> some systematic bias with respect to the ideal distribution </a:t>
+                </a:r>
+              </a:p>
+              <a:p>
+                <a:pPr>
+                  <a:buFont typeface="Arial" panose="020B0604020202020204" pitchFamily="34" charset="0"/>
+                  <a:buChar char="•"/>
+                </a:pPr>
+                <a:r>
+                  <a:rPr lang="en-US" dirty="0"/>
+                  <a:t>Sampled mean distribution is skewed with respect to the observed   </a:t>
                 </a:r>
               </a:p>
               <a:p>
@@ -22141,6 +22496,33 @@
                                   </p:childTnLst>
                                 </p:cTn>
                               </p:par>
+                              <p:par>
+                                <p:cTn id="7" presetID="1" presetClass="entr" presetSubtype="0" fill="hold" nodeType="withEffect">
+                                  <p:stCondLst>
+                                    <p:cond delay="0"/>
+                                  </p:stCondLst>
+                                  <p:childTnLst>
+                                    <p:set>
+                                      <p:cBhvr>
+                                        <p:cTn id="8" dur="1" fill="hold">
+                                          <p:stCondLst>
+                                            <p:cond delay="0"/>
+                                          </p:stCondLst>
+                                        </p:cTn>
+                                        <p:tgtEl>
+                                          <p:spTgt spid="5"/>
+                                        </p:tgtEl>
+                                        <p:attrNameLst>
+                                          <p:attrName>style.visibility</p:attrName>
+                                        </p:attrNameLst>
+                                      </p:cBhvr>
+                                      <p:to>
+                                        <p:strVal val="visible"/>
+                                      </p:to>
+                                    </p:set>
+                                  </p:childTnLst>
+                                </p:cTn>
+                              </p:par>
                             </p:childTnLst>
                           </p:cTn>
                         </p:par>
@@ -22148,26 +22530,26 @@
                     </p:cTn>
                   </p:par>
                   <p:par>
-                    <p:cTn id="7" fill="hold">
+                    <p:cTn id="9" fill="hold">
                       <p:stCondLst>
                         <p:cond delay="indefinite"/>
                       </p:stCondLst>
                       <p:childTnLst>
                         <p:par>
-                          <p:cTn id="8" fill="hold">
+                          <p:cTn id="10" fill="hold">
                             <p:stCondLst>
                               <p:cond delay="0"/>
                             </p:stCondLst>
                             <p:childTnLst>
                               <p:par>
-                                <p:cTn id="9" presetID="1" presetClass="entr" presetSubtype="0" fill="hold" nodeType="clickEffect">
+                                <p:cTn id="11" presetID="1" presetClass="entr" presetSubtype="0" fill="hold" nodeType="clickEffect">
                                   <p:stCondLst>
                                     <p:cond delay="0"/>
                                   </p:stCondLst>
                                   <p:childTnLst>
                                     <p:set>
                                       <p:cBhvr>
-                                        <p:cTn id="10" dur="1" fill="hold">
+                                        <p:cTn id="12" dur="1" fill="hold">
                                           <p:stCondLst>
                                             <p:cond delay="0"/>
                                           </p:stCondLst>
@@ -22197,26 +22579,26 @@
                     </p:cTn>
                   </p:par>
                   <p:par>
-                    <p:cTn id="11" fill="hold">
+                    <p:cTn id="13" fill="hold">
                       <p:stCondLst>
                         <p:cond delay="indefinite"/>
                       </p:stCondLst>
                       <p:childTnLst>
                         <p:par>
-                          <p:cTn id="12" fill="hold">
+                          <p:cTn id="14" fill="hold">
                             <p:stCondLst>
                               <p:cond delay="0"/>
                             </p:stCondLst>
                             <p:childTnLst>
                               <p:par>
-                                <p:cTn id="13" presetID="1" presetClass="entr" presetSubtype="0" fill="hold" nodeType="clickEffect">
+                                <p:cTn id="15" presetID="1" presetClass="entr" presetSubtype="0" fill="hold" nodeType="clickEffect">
                                   <p:stCondLst>
                                     <p:cond delay="0"/>
                                   </p:stCondLst>
                                   <p:childTnLst>
                                     <p:set>
                                       <p:cBhvr>
-                                        <p:cTn id="14" dur="1" fill="hold">
+                                        <p:cTn id="16" dur="1" fill="hold">
                                           <p:stCondLst>
                                             <p:cond delay="0"/>
                                           </p:stCondLst>
@@ -22595,6 +22977,183 @@
   <p:clrMapOvr>
     <a:masterClrMapping/>
   </p:clrMapOvr>
+  <p:timing>
+    <p:tnLst>
+      <p:par>
+        <p:cTn id="1" dur="indefinite" restart="never" nodeType="tmRoot">
+          <p:childTnLst>
+            <p:seq concurrent="1" nextAc="seek">
+              <p:cTn id="2" dur="indefinite" nodeType="mainSeq">
+                <p:childTnLst>
+                  <p:par>
+                    <p:cTn id="3" fill="hold">
+                      <p:stCondLst>
+                        <p:cond delay="indefinite"/>
+                      </p:stCondLst>
+                      <p:childTnLst>
+                        <p:par>
+                          <p:cTn id="4" fill="hold">
+                            <p:stCondLst>
+                              <p:cond delay="0"/>
+                            </p:stCondLst>
+                            <p:childTnLst>
+                              <p:par>
+                                <p:cTn id="5" presetID="1" presetClass="entr" presetSubtype="0" fill="hold" nodeType="clickEffect">
+                                  <p:stCondLst>
+                                    <p:cond delay="0"/>
+                                  </p:stCondLst>
+                                  <p:childTnLst>
+                                    <p:set>
+                                      <p:cBhvr>
+                                        <p:cTn id="6" dur="1" fill="hold">
+                                          <p:stCondLst>
+                                            <p:cond delay="0"/>
+                                          </p:stCondLst>
+                                        </p:cTn>
+                                        <p:tgtEl>
+                                          <p:spTgt spid="5">
+                                            <p:txEl>
+                                              <p:pRg st="1" end="1"/>
+                                            </p:txEl>
+                                          </p:spTgt>
+                                        </p:tgtEl>
+                                        <p:attrNameLst>
+                                          <p:attrName>style.visibility</p:attrName>
+                                        </p:attrNameLst>
+                                      </p:cBhvr>
+                                      <p:to>
+                                        <p:strVal val="visible"/>
+                                      </p:to>
+                                    </p:set>
+                                  </p:childTnLst>
+                                </p:cTn>
+                              </p:par>
+                            </p:childTnLst>
+                          </p:cTn>
+                        </p:par>
+                      </p:childTnLst>
+                    </p:cTn>
+                  </p:par>
+                  <p:par>
+                    <p:cTn id="7" fill="hold">
+                      <p:stCondLst>
+                        <p:cond delay="indefinite"/>
+                      </p:stCondLst>
+                      <p:childTnLst>
+                        <p:par>
+                          <p:cTn id="8" fill="hold">
+                            <p:stCondLst>
+                              <p:cond delay="0"/>
+                            </p:stCondLst>
+                            <p:childTnLst>
+                              <p:par>
+                                <p:cTn id="9" presetID="1" presetClass="entr" presetSubtype="0" fill="hold" nodeType="clickEffect">
+                                  <p:stCondLst>
+                                    <p:cond delay="0"/>
+                                  </p:stCondLst>
+                                  <p:childTnLst>
+                                    <p:set>
+                                      <p:cBhvr>
+                                        <p:cTn id="10" dur="1" fill="hold">
+                                          <p:stCondLst>
+                                            <p:cond delay="0"/>
+                                          </p:stCondLst>
+                                        </p:cTn>
+                                        <p:tgtEl>
+                                          <p:spTgt spid="5">
+                                            <p:txEl>
+                                              <p:pRg st="2" end="2"/>
+                                            </p:txEl>
+                                          </p:spTgt>
+                                        </p:tgtEl>
+                                        <p:attrNameLst>
+                                          <p:attrName>style.visibility</p:attrName>
+                                        </p:attrNameLst>
+                                      </p:cBhvr>
+                                      <p:to>
+                                        <p:strVal val="visible"/>
+                                      </p:to>
+                                    </p:set>
+                                  </p:childTnLst>
+                                </p:cTn>
+                              </p:par>
+                            </p:childTnLst>
+                          </p:cTn>
+                        </p:par>
+                      </p:childTnLst>
+                    </p:cTn>
+                  </p:par>
+                  <p:par>
+                    <p:cTn id="11" fill="hold">
+                      <p:stCondLst>
+                        <p:cond delay="indefinite"/>
+                      </p:stCondLst>
+                      <p:childTnLst>
+                        <p:par>
+                          <p:cTn id="12" fill="hold">
+                            <p:stCondLst>
+                              <p:cond delay="0"/>
+                            </p:stCondLst>
+                            <p:childTnLst>
+                              <p:par>
+                                <p:cTn id="13" presetID="1" presetClass="entr" presetSubtype="0" fill="hold" nodeType="clickEffect">
+                                  <p:stCondLst>
+                                    <p:cond delay="0"/>
+                                  </p:stCondLst>
+                                  <p:childTnLst>
+                                    <p:set>
+                                      <p:cBhvr>
+                                        <p:cTn id="14" dur="1" fill="hold">
+                                          <p:stCondLst>
+                                            <p:cond delay="0"/>
+                                          </p:stCondLst>
+                                        </p:cTn>
+                                        <p:tgtEl>
+                                          <p:spTgt spid="5">
+                                            <p:txEl>
+                                              <p:pRg st="3" end="3"/>
+                                            </p:txEl>
+                                          </p:spTgt>
+                                        </p:tgtEl>
+                                        <p:attrNameLst>
+                                          <p:attrName>style.visibility</p:attrName>
+                                        </p:attrNameLst>
+                                      </p:cBhvr>
+                                      <p:to>
+                                        <p:strVal val="visible"/>
+                                      </p:to>
+                                    </p:set>
+                                  </p:childTnLst>
+                                </p:cTn>
+                              </p:par>
+                            </p:childTnLst>
+                          </p:cTn>
+                        </p:par>
+                      </p:childTnLst>
+                    </p:cTn>
+                  </p:par>
+                </p:childTnLst>
+              </p:cTn>
+              <p:prevCondLst>
+                <p:cond evt="onPrev" delay="0">
+                  <p:tgtEl>
+                    <p:sldTgt/>
+                  </p:tgtEl>
+                </p:cond>
+              </p:prevCondLst>
+              <p:nextCondLst>
+                <p:cond evt="onNext" delay="0">
+                  <p:tgtEl>
+                    <p:sldTgt/>
+                  </p:tgtEl>
+                </p:cond>
+              </p:nextCondLst>
+            </p:seq>
+          </p:childTnLst>
+        </p:cTn>
+      </p:par>
+    </p:tnLst>
+  </p:timing>
 </p:sld>
 </file>
 
@@ -22879,6 +23438,134 @@
   <p:clrMapOvr>
     <a:masterClrMapping/>
   </p:clrMapOvr>
+  <p:timing>
+    <p:tnLst>
+      <p:par>
+        <p:cTn id="1" dur="indefinite" restart="never" nodeType="tmRoot">
+          <p:childTnLst>
+            <p:seq concurrent="1" nextAc="seek">
+              <p:cTn id="2" dur="indefinite" nodeType="mainSeq">
+                <p:childTnLst>
+                  <p:par>
+                    <p:cTn id="3" fill="hold">
+                      <p:stCondLst>
+                        <p:cond delay="indefinite"/>
+                      </p:stCondLst>
+                      <p:childTnLst>
+                        <p:par>
+                          <p:cTn id="4" fill="hold">
+                            <p:stCondLst>
+                              <p:cond delay="0"/>
+                            </p:stCondLst>
+                            <p:childTnLst>
+                              <p:par>
+                                <p:cTn id="5" presetID="1" presetClass="entr" presetSubtype="0" fill="hold" nodeType="clickEffect">
+                                  <p:stCondLst>
+                                    <p:cond delay="0"/>
+                                  </p:stCondLst>
+                                  <p:childTnLst>
+                                    <p:set>
+                                      <p:cBhvr>
+                                        <p:cTn id="6" dur="1" fill="hold">
+                                          <p:stCondLst>
+                                            <p:cond delay="0"/>
+                                          </p:stCondLst>
+                                        </p:cTn>
+                                        <p:tgtEl>
+                                          <p:spTgt spid="5">
+                                            <p:txEl>
+                                              <p:pRg st="1" end="1"/>
+                                            </p:txEl>
+                                          </p:spTgt>
+                                        </p:tgtEl>
+                                        <p:attrNameLst>
+                                          <p:attrName>style.visibility</p:attrName>
+                                        </p:attrNameLst>
+                                      </p:cBhvr>
+                                      <p:to>
+                                        <p:strVal val="visible"/>
+                                      </p:to>
+                                    </p:set>
+                                  </p:childTnLst>
+                                </p:cTn>
+                              </p:par>
+                            </p:childTnLst>
+                          </p:cTn>
+                        </p:par>
+                      </p:childTnLst>
+                    </p:cTn>
+                  </p:par>
+                  <p:par>
+                    <p:cTn id="7" fill="hold">
+                      <p:stCondLst>
+                        <p:cond delay="indefinite"/>
+                      </p:stCondLst>
+                      <p:childTnLst>
+                        <p:par>
+                          <p:cTn id="8" fill="hold">
+                            <p:stCondLst>
+                              <p:cond delay="0"/>
+                            </p:stCondLst>
+                            <p:childTnLst>
+                              <p:par>
+                                <p:cTn id="9" presetID="1" presetClass="entr" presetSubtype="0" fill="hold" nodeType="clickEffect">
+                                  <p:stCondLst>
+                                    <p:cond delay="0"/>
+                                  </p:stCondLst>
+                                  <p:childTnLst>
+                                    <p:set>
+                                      <p:cBhvr>
+                                        <p:cTn id="10" dur="1" fill="hold">
+                                          <p:stCondLst>
+                                            <p:cond delay="0"/>
+                                          </p:stCondLst>
+                                        </p:cTn>
+                                        <p:tgtEl>
+                                          <p:spTgt spid="5">
+                                            <p:txEl>
+                                              <p:pRg st="2" end="2"/>
+                                            </p:txEl>
+                                          </p:spTgt>
+                                        </p:tgtEl>
+                                        <p:attrNameLst>
+                                          <p:attrName>style.visibility</p:attrName>
+                                        </p:attrNameLst>
+                                      </p:cBhvr>
+                                      <p:to>
+                                        <p:strVal val="visible"/>
+                                      </p:to>
+                                    </p:set>
+                                  </p:childTnLst>
+                                </p:cTn>
+                              </p:par>
+                            </p:childTnLst>
+                          </p:cTn>
+                        </p:par>
+                      </p:childTnLst>
+                    </p:cTn>
+                  </p:par>
+                </p:childTnLst>
+              </p:cTn>
+              <p:prevCondLst>
+                <p:cond evt="onPrev" delay="0">
+                  <p:tgtEl>
+                    <p:sldTgt/>
+                  </p:tgtEl>
+                </p:cond>
+              </p:prevCondLst>
+              <p:nextCondLst>
+                <p:cond evt="onNext" delay="0">
+                  <p:tgtEl>
+                    <p:sldTgt/>
+                  </p:tgtEl>
+                </p:cond>
+              </p:nextCondLst>
+            </p:seq>
+          </p:childTnLst>
+        </p:cTn>
+      </p:par>
+    </p:tnLst>
+  </p:timing>
 </p:sld>
 </file>
 
@@ -23416,8 +24103,8 @@
           </a:p>
         </p:txBody>
       </p:sp>
-      <mc:AlternateContent xmlns:mc="http://schemas.openxmlformats.org/markup-compatibility/2006" xmlns:a14="http://schemas.microsoft.com/office/drawing/2010/main">
-        <mc:Choice Requires="a14">
+      <mc:AlternateContent xmlns:mc="http://schemas.openxmlformats.org/markup-compatibility/2006">
+        <mc:Choice xmlns:a14="http://schemas.microsoft.com/office/drawing/2010/main" Requires="a14">
           <p:sp>
             <p:nvSpPr>
               <p:cNvPr id="3" name="Content Placeholder 2">
@@ -23442,7 +24129,7 @@
             </p:spPr>
             <p:txBody>
               <a:bodyPr>
-                <a:normAutofit fontScale="77500" lnSpcReduction="20000"/>
+                <a:normAutofit fontScale="85000" lnSpcReduction="20000"/>
               </a:bodyPr>
               <a:lstStyle/>
               <a:p>
@@ -24001,6 +24688,96 @@
                 <a14:m>
                   <m:oMath xmlns:m="http://schemas.openxmlformats.org/officeDocument/2006/math">
                     <m:r>
+                      <a:rPr lang="en-US" i="1">
+                        <a:latin typeface="Cambria Math" panose="02040503050406030204" pitchFamily="18" charset="0"/>
+                      </a:rPr>
+                      <m:t>𝑝</m:t>
+                    </m:r>
+                    <m:d>
+                      <m:dPr>
+                        <m:ctrlPr>
+                          <a:rPr lang="en-US" i="1">
+                            <a:latin typeface="Cambria Math" panose="02040503050406030204" pitchFamily="18" charset="0"/>
+                            <a:ea typeface="Cambria Math" panose="02040503050406030204" pitchFamily="18" charset="0"/>
+                          </a:rPr>
+                        </m:ctrlPr>
+                      </m:dPr>
+                      <m:e>
+                        <m:r>
+                          <a:rPr lang="en-US" i="1">
+                            <a:latin typeface="Cambria Math" panose="02040503050406030204" pitchFamily="18" charset="0"/>
+                            <a:ea typeface="Cambria Math" panose="02040503050406030204" pitchFamily="18" charset="0"/>
+                          </a:rPr>
+                          <m:t>𝜃</m:t>
+                        </m:r>
+                        <m:r>
+                          <a:rPr lang="en-US" i="1">
+                            <a:latin typeface="Cambria Math" panose="02040503050406030204" pitchFamily="18" charset="0"/>
+                            <a:ea typeface="Cambria Math" panose="02040503050406030204" pitchFamily="18" charset="0"/>
+                          </a:rPr>
+                          <m:t> | </m:t>
+                        </m:r>
+                        <m:sSub>
+                          <m:sSubPr>
+                            <m:ctrlPr>
+                              <a:rPr lang="en-US" i="1">
+                                <a:latin typeface="Cambria Math" panose="02040503050406030204" pitchFamily="18" charset="0"/>
+                                <a:ea typeface="Cambria Math" panose="02040503050406030204" pitchFamily="18" charset="0"/>
+                              </a:rPr>
+                            </m:ctrlPr>
+                          </m:sSubPr>
+                          <m:e>
+                            <m:r>
+                              <a:rPr lang="en-US" i="1">
+                                <a:latin typeface="Cambria Math" panose="02040503050406030204" pitchFamily="18" charset="0"/>
+                                <a:ea typeface="Cambria Math" panose="02040503050406030204" pitchFamily="18" charset="0"/>
+                              </a:rPr>
+                              <m:t>𝑦</m:t>
+                            </m:r>
+                          </m:e>
+                          <m:sub>
+                            <m:r>
+                              <a:rPr lang="en-US" i="1">
+                                <a:latin typeface="Cambria Math" panose="02040503050406030204" pitchFamily="18" charset="0"/>
+                                <a:ea typeface="Cambria Math" panose="02040503050406030204" pitchFamily="18" charset="0"/>
+                              </a:rPr>
+                              <m:t>−</m:t>
+                            </m:r>
+                            <m:r>
+                              <a:rPr lang="en-US" i="1">
+                                <a:latin typeface="Cambria Math" panose="02040503050406030204" pitchFamily="18" charset="0"/>
+                                <a:ea typeface="Cambria Math" panose="02040503050406030204" pitchFamily="18" charset="0"/>
+                              </a:rPr>
+                              <m:t>𝑖</m:t>
+                            </m:r>
+                          </m:sub>
+                        </m:sSub>
+                      </m:e>
+                    </m:d>
+                    <m:r>
+                      <a:rPr lang="en-US" i="1">
+                        <a:latin typeface="Cambria Math" panose="02040503050406030204" pitchFamily="18" charset="0"/>
+                        <a:ea typeface="Cambria Math" panose="02040503050406030204" pitchFamily="18" charset="0"/>
+                      </a:rPr>
+                      <m:t>=</m:t>
+                    </m:r>
+                  </m:oMath>
+                </a14:m>
+                <a:r>
+                  <a:rPr lang="en-US" dirty="0"/>
+                  <a:t> LOO posterior density computed without the </a:t>
+                </a:r>
+                <a:r>
+                  <a:rPr lang="en-US" i="1" dirty="0" err="1"/>
+                  <a:t>ith</a:t>
+                </a:r>
+                <a:r>
+                  <a:rPr lang="en-US" dirty="0"/>
+                  <a:t> observation </a:t>
+                </a:r>
+                <a14:m>
+                  <m:oMath xmlns:m="http://schemas.openxmlformats.org/officeDocument/2006/math">
+                    <m:r>
                       <a:rPr lang="en-US" b="0" i="1" smtClean="0">
                         <a:latin typeface="Cambria Math" panose="02040503050406030204" pitchFamily="18" charset="0"/>
                       </a:rPr>
@@ -24126,102 +24903,7 @@
                 </a14:m>
                 <a:r>
                   <a:rPr lang="en-US" dirty="0"/>
-                  <a:t> </a:t>
-                </a:r>
-              </a:p>
-              <a:p>
-                <a:pPr marL="342900" lvl="1" indent="0">
-                  <a:buNone/>
-                </a:pPr>
-                <a14:m>
-                  <m:oMath xmlns:m="http://schemas.openxmlformats.org/officeDocument/2006/math">
-                    <m:r>
-                      <a:rPr lang="en-US" b="0" i="1" smtClean="0">
-                        <a:latin typeface="Cambria Math" panose="02040503050406030204" pitchFamily="18" charset="0"/>
-                      </a:rPr>
-                      <m:t>𝑝</m:t>
-                    </m:r>
-                    <m:d>
-                      <m:dPr>
-                        <m:ctrlPr>
-                          <a:rPr lang="en-US" b="0" i="1" smtClean="0">
-                            <a:latin typeface="Cambria Math" panose="02040503050406030204" pitchFamily="18" charset="0"/>
-                            <a:ea typeface="Cambria Math" panose="02040503050406030204" pitchFamily="18" charset="0"/>
-                          </a:rPr>
-                        </m:ctrlPr>
-                      </m:dPr>
-                      <m:e>
-                        <m:r>
-                          <a:rPr lang="en-US" b="0" i="1" smtClean="0">
-                            <a:latin typeface="Cambria Math" panose="02040503050406030204" pitchFamily="18" charset="0"/>
-                            <a:ea typeface="Cambria Math" panose="02040503050406030204" pitchFamily="18" charset="0"/>
-                          </a:rPr>
-                          <m:t>𝜃</m:t>
-                        </m:r>
-                        <m:r>
-                          <a:rPr lang="en-US" b="0" i="1" smtClean="0">
-                            <a:latin typeface="Cambria Math" panose="02040503050406030204" pitchFamily="18" charset="0"/>
-                            <a:ea typeface="Cambria Math" panose="02040503050406030204" pitchFamily="18" charset="0"/>
-                          </a:rPr>
-                          <m:t> | </m:t>
-                        </m:r>
-                        <m:sSub>
-                          <m:sSubPr>
-                            <m:ctrlPr>
-                              <a:rPr lang="en-US" b="0" i="1" smtClean="0">
-                                <a:latin typeface="Cambria Math" panose="02040503050406030204" pitchFamily="18" charset="0"/>
-                                <a:ea typeface="Cambria Math" panose="02040503050406030204" pitchFamily="18" charset="0"/>
-                              </a:rPr>
-                            </m:ctrlPr>
-                          </m:sSubPr>
-                          <m:e>
-                            <m:r>
-                              <a:rPr lang="en-US" b="0" i="1" smtClean="0">
-                                <a:latin typeface="Cambria Math" panose="02040503050406030204" pitchFamily="18" charset="0"/>
-                                <a:ea typeface="Cambria Math" panose="02040503050406030204" pitchFamily="18" charset="0"/>
-                              </a:rPr>
-                              <m:t>𝑦</m:t>
-                            </m:r>
-                          </m:e>
-                          <m:sub>
-                            <m:r>
-                              <a:rPr lang="en-US" b="0" i="1" smtClean="0">
-                                <a:latin typeface="Cambria Math" panose="02040503050406030204" pitchFamily="18" charset="0"/>
-                                <a:ea typeface="Cambria Math" panose="02040503050406030204" pitchFamily="18" charset="0"/>
-                              </a:rPr>
-                              <m:t>−</m:t>
-                            </m:r>
-                            <m:r>
-                              <a:rPr lang="en-US" b="0" i="1" smtClean="0">
-                                <a:latin typeface="Cambria Math" panose="02040503050406030204" pitchFamily="18" charset="0"/>
-                                <a:ea typeface="Cambria Math" panose="02040503050406030204" pitchFamily="18" charset="0"/>
-                              </a:rPr>
-                              <m:t>𝑖</m:t>
-                            </m:r>
-                          </m:sub>
-                        </m:sSub>
-                      </m:e>
-                    </m:d>
-                    <m:r>
-                      <a:rPr lang="en-US" b="0" i="1" smtClean="0">
-                        <a:latin typeface="Cambria Math" panose="02040503050406030204" pitchFamily="18" charset="0"/>
-                        <a:ea typeface="Cambria Math" panose="02040503050406030204" pitchFamily="18" charset="0"/>
-                      </a:rPr>
-                      <m:t>=</m:t>
-                    </m:r>
-                  </m:oMath>
-                </a14:m>
-                <a:r>
-                  <a:rPr lang="en-US" dirty="0"/>
-                  <a:t> LOO posterior density computed without the </a:t>
-                </a:r>
-                <a:r>
-                  <a:rPr lang="en-US" i="1" dirty="0" err="1"/>
-                  <a:t>ith</a:t>
-                </a:r>
-                <a:r>
-                  <a:rPr lang="en-US" dirty="0"/>
-                  <a:t> observation </a:t>
+                  <a:t>  </a:t>
                 </a:r>
               </a:p>
               <a:p>
@@ -24239,7 +24921,7 @@
             </p:txBody>
           </p:sp>
         </mc:Choice>
-        <mc:Fallback xmlns="">
+        <mc:Fallback>
           <p:sp>
             <p:nvSpPr>
               <p:cNvPr id="3" name="Content Placeholder 2">
@@ -24264,7 +24946,7 @@
               <a:blipFill>
                 <a:blip r:embed="rId2"/>
                 <a:stretch>
-                  <a:fillRect l="-667" t="-2124"/>
+                  <a:fillRect l="-741" t="-2288" b="-1961"/>
                 </a:stretch>
               </a:blipFill>
             </p:spPr>
@@ -24614,37 +25296,6 @@
                                           <p:spTgt spid="3">
                                             <p:txEl>
                                               <p:pRg st="9" end="9"/>
-                                            </p:txEl>
-                                          </p:spTgt>
-                                        </p:tgtEl>
-                                        <p:attrNameLst>
-                                          <p:attrName>style.visibility</p:attrName>
-                                        </p:attrNameLst>
-                                      </p:cBhvr>
-                                      <p:to>
-                                        <p:strVal val="visible"/>
-                                      </p:to>
-                                    </p:set>
-                                  </p:childTnLst>
-                                </p:cTn>
-                              </p:par>
-                              <p:par>
-                                <p:cTn id="27" presetID="1" presetClass="entr" presetSubtype="0" fill="hold" nodeType="withEffect">
-                                  <p:stCondLst>
-                                    <p:cond delay="0"/>
-                                  </p:stCondLst>
-                                  <p:childTnLst>
-                                    <p:set>
-                                      <p:cBhvr>
-                                        <p:cTn id="28" dur="1" fill="hold">
-                                          <p:stCondLst>
-                                            <p:cond delay="0"/>
-                                          </p:stCondLst>
-                                        </p:cTn>
-                                        <p:tgtEl>
-                                          <p:spTgt spid="3">
-                                            <p:txEl>
-                                              <p:pRg st="10" end="10"/>
                                             </p:txEl>
                                           </p:spTgt>
                                         </p:tgtEl>
@@ -25779,6 +26430,356 @@
   <p:clrMapOvr>
     <a:masterClrMapping/>
   </p:clrMapOvr>
+  <p:timing>
+    <p:tnLst>
+      <p:par>
+        <p:cTn id="1" dur="indefinite" restart="never" nodeType="tmRoot">
+          <p:childTnLst>
+            <p:seq concurrent="1" nextAc="seek">
+              <p:cTn id="2" dur="indefinite" nodeType="mainSeq">
+                <p:childTnLst>
+                  <p:par>
+                    <p:cTn id="3" fill="hold">
+                      <p:stCondLst>
+                        <p:cond delay="indefinite"/>
+                      </p:stCondLst>
+                      <p:childTnLst>
+                        <p:par>
+                          <p:cTn id="4" fill="hold">
+                            <p:stCondLst>
+                              <p:cond delay="0"/>
+                            </p:stCondLst>
+                            <p:childTnLst>
+                              <p:par>
+                                <p:cTn id="5" presetID="1" presetClass="entr" presetSubtype="0" fill="hold" nodeType="clickEffect">
+                                  <p:stCondLst>
+                                    <p:cond delay="0"/>
+                                  </p:stCondLst>
+                                  <p:childTnLst>
+                                    <p:set>
+                                      <p:cBhvr>
+                                        <p:cTn id="6" dur="1" fill="hold">
+                                          <p:stCondLst>
+                                            <p:cond delay="0"/>
+                                          </p:stCondLst>
+                                        </p:cTn>
+                                        <p:tgtEl>
+                                          <p:spTgt spid="3">
+                                            <p:txEl>
+                                              <p:pRg st="1" end="1"/>
+                                            </p:txEl>
+                                          </p:spTgt>
+                                        </p:tgtEl>
+                                        <p:attrNameLst>
+                                          <p:attrName>style.visibility</p:attrName>
+                                        </p:attrNameLst>
+                                      </p:cBhvr>
+                                      <p:to>
+                                        <p:strVal val="visible"/>
+                                      </p:to>
+                                    </p:set>
+                                  </p:childTnLst>
+                                </p:cTn>
+                              </p:par>
+                              <p:par>
+                                <p:cTn id="7" presetID="1" presetClass="entr" presetSubtype="0" fill="hold" nodeType="withEffect">
+                                  <p:stCondLst>
+                                    <p:cond delay="0"/>
+                                  </p:stCondLst>
+                                  <p:childTnLst>
+                                    <p:set>
+                                      <p:cBhvr>
+                                        <p:cTn id="8" dur="1" fill="hold">
+                                          <p:stCondLst>
+                                            <p:cond delay="0"/>
+                                          </p:stCondLst>
+                                        </p:cTn>
+                                        <p:tgtEl>
+                                          <p:spTgt spid="3">
+                                            <p:txEl>
+                                              <p:pRg st="2" end="2"/>
+                                            </p:txEl>
+                                          </p:spTgt>
+                                        </p:tgtEl>
+                                        <p:attrNameLst>
+                                          <p:attrName>style.visibility</p:attrName>
+                                        </p:attrNameLst>
+                                      </p:cBhvr>
+                                      <p:to>
+                                        <p:strVal val="visible"/>
+                                      </p:to>
+                                    </p:set>
+                                  </p:childTnLst>
+                                </p:cTn>
+                              </p:par>
+                            </p:childTnLst>
+                          </p:cTn>
+                        </p:par>
+                      </p:childTnLst>
+                    </p:cTn>
+                  </p:par>
+                  <p:par>
+                    <p:cTn id="9" fill="hold">
+                      <p:stCondLst>
+                        <p:cond delay="indefinite"/>
+                      </p:stCondLst>
+                      <p:childTnLst>
+                        <p:par>
+                          <p:cTn id="10" fill="hold">
+                            <p:stCondLst>
+                              <p:cond delay="0"/>
+                            </p:stCondLst>
+                            <p:childTnLst>
+                              <p:par>
+                                <p:cTn id="11" presetID="1" presetClass="entr" presetSubtype="0" fill="hold" nodeType="clickEffect">
+                                  <p:stCondLst>
+                                    <p:cond delay="0"/>
+                                  </p:stCondLst>
+                                  <p:childTnLst>
+                                    <p:set>
+                                      <p:cBhvr>
+                                        <p:cTn id="12" dur="1" fill="hold">
+                                          <p:stCondLst>
+                                            <p:cond delay="0"/>
+                                          </p:stCondLst>
+                                        </p:cTn>
+                                        <p:tgtEl>
+                                          <p:spTgt spid="3">
+                                            <p:txEl>
+                                              <p:pRg st="3" end="3"/>
+                                            </p:txEl>
+                                          </p:spTgt>
+                                        </p:tgtEl>
+                                        <p:attrNameLst>
+                                          <p:attrName>style.visibility</p:attrName>
+                                        </p:attrNameLst>
+                                      </p:cBhvr>
+                                      <p:to>
+                                        <p:strVal val="visible"/>
+                                      </p:to>
+                                    </p:set>
+                                  </p:childTnLst>
+                                </p:cTn>
+                              </p:par>
+                              <p:par>
+                                <p:cTn id="13" presetID="1" presetClass="entr" presetSubtype="0" fill="hold" nodeType="withEffect">
+                                  <p:stCondLst>
+                                    <p:cond delay="0"/>
+                                  </p:stCondLst>
+                                  <p:childTnLst>
+                                    <p:set>
+                                      <p:cBhvr>
+                                        <p:cTn id="14" dur="1" fill="hold">
+                                          <p:stCondLst>
+                                            <p:cond delay="0"/>
+                                          </p:stCondLst>
+                                        </p:cTn>
+                                        <p:tgtEl>
+                                          <p:spTgt spid="3">
+                                            <p:txEl>
+                                              <p:pRg st="4" end="4"/>
+                                            </p:txEl>
+                                          </p:spTgt>
+                                        </p:tgtEl>
+                                        <p:attrNameLst>
+                                          <p:attrName>style.visibility</p:attrName>
+                                        </p:attrNameLst>
+                                      </p:cBhvr>
+                                      <p:to>
+                                        <p:strVal val="visible"/>
+                                      </p:to>
+                                    </p:set>
+                                  </p:childTnLst>
+                                </p:cTn>
+                              </p:par>
+                            </p:childTnLst>
+                          </p:cTn>
+                        </p:par>
+                      </p:childTnLst>
+                    </p:cTn>
+                  </p:par>
+                  <p:par>
+                    <p:cTn id="15" fill="hold">
+                      <p:stCondLst>
+                        <p:cond delay="indefinite"/>
+                      </p:stCondLst>
+                      <p:childTnLst>
+                        <p:par>
+                          <p:cTn id="16" fill="hold">
+                            <p:stCondLst>
+                              <p:cond delay="0"/>
+                            </p:stCondLst>
+                            <p:childTnLst>
+                              <p:par>
+                                <p:cTn id="17" presetID="1" presetClass="entr" presetSubtype="0" fill="hold" nodeType="clickEffect">
+                                  <p:stCondLst>
+                                    <p:cond delay="0"/>
+                                  </p:stCondLst>
+                                  <p:childTnLst>
+                                    <p:set>
+                                      <p:cBhvr>
+                                        <p:cTn id="18" dur="1" fill="hold">
+                                          <p:stCondLst>
+                                            <p:cond delay="0"/>
+                                          </p:stCondLst>
+                                        </p:cTn>
+                                        <p:tgtEl>
+                                          <p:spTgt spid="3">
+                                            <p:txEl>
+                                              <p:pRg st="5" end="5"/>
+                                            </p:txEl>
+                                          </p:spTgt>
+                                        </p:tgtEl>
+                                        <p:attrNameLst>
+                                          <p:attrName>style.visibility</p:attrName>
+                                        </p:attrNameLst>
+                                      </p:cBhvr>
+                                      <p:to>
+                                        <p:strVal val="visible"/>
+                                      </p:to>
+                                    </p:set>
+                                  </p:childTnLst>
+                                </p:cTn>
+                              </p:par>
+                            </p:childTnLst>
+                          </p:cTn>
+                        </p:par>
+                      </p:childTnLst>
+                    </p:cTn>
+                  </p:par>
+                  <p:par>
+                    <p:cTn id="19" fill="hold">
+                      <p:stCondLst>
+                        <p:cond delay="indefinite"/>
+                      </p:stCondLst>
+                      <p:childTnLst>
+                        <p:par>
+                          <p:cTn id="20" fill="hold">
+                            <p:stCondLst>
+                              <p:cond delay="0"/>
+                            </p:stCondLst>
+                            <p:childTnLst>
+                              <p:par>
+                                <p:cTn id="21" presetID="1" presetClass="entr" presetSubtype="0" fill="hold" nodeType="clickEffect">
+                                  <p:stCondLst>
+                                    <p:cond delay="0"/>
+                                  </p:stCondLst>
+                                  <p:childTnLst>
+                                    <p:set>
+                                      <p:cBhvr>
+                                        <p:cTn id="22" dur="1" fill="hold">
+                                          <p:stCondLst>
+                                            <p:cond delay="0"/>
+                                          </p:stCondLst>
+                                        </p:cTn>
+                                        <p:tgtEl>
+                                          <p:spTgt spid="3">
+                                            <p:txEl>
+                                              <p:pRg st="6" end="6"/>
+                                            </p:txEl>
+                                          </p:spTgt>
+                                        </p:tgtEl>
+                                        <p:attrNameLst>
+                                          <p:attrName>style.visibility</p:attrName>
+                                        </p:attrNameLst>
+                                      </p:cBhvr>
+                                      <p:to>
+                                        <p:strVal val="visible"/>
+                                      </p:to>
+                                    </p:set>
+                                  </p:childTnLst>
+                                </p:cTn>
+                              </p:par>
+                              <p:par>
+                                <p:cTn id="23" presetID="1" presetClass="entr" presetSubtype="0" fill="hold" nodeType="withEffect">
+                                  <p:stCondLst>
+                                    <p:cond delay="0"/>
+                                  </p:stCondLst>
+                                  <p:childTnLst>
+                                    <p:set>
+                                      <p:cBhvr>
+                                        <p:cTn id="24" dur="1" fill="hold">
+                                          <p:stCondLst>
+                                            <p:cond delay="0"/>
+                                          </p:stCondLst>
+                                        </p:cTn>
+                                        <p:tgtEl>
+                                          <p:spTgt spid="3">
+                                            <p:txEl>
+                                              <p:pRg st="7" end="7"/>
+                                            </p:txEl>
+                                          </p:spTgt>
+                                        </p:tgtEl>
+                                        <p:attrNameLst>
+                                          <p:attrName>style.visibility</p:attrName>
+                                        </p:attrNameLst>
+                                      </p:cBhvr>
+                                      <p:to>
+                                        <p:strVal val="visible"/>
+                                      </p:to>
+                                    </p:set>
+                                  </p:childTnLst>
+                                </p:cTn>
+                              </p:par>
+                              <p:par>
+                                <p:cTn id="25" presetID="1" presetClass="entr" presetSubtype="0" fill="hold" nodeType="withEffect">
+                                  <p:stCondLst>
+                                    <p:cond delay="0"/>
+                                  </p:stCondLst>
+                                  <p:childTnLst>
+                                    <p:set>
+                                      <p:cBhvr>
+                                        <p:cTn id="26" dur="1" fill="hold">
+                                          <p:stCondLst>
+                                            <p:cond delay="0"/>
+                                          </p:stCondLst>
+                                        </p:cTn>
+                                        <p:tgtEl>
+                                          <p:spTgt spid="3">
+                                            <p:txEl>
+                                              <p:pRg st="8" end="8"/>
+                                            </p:txEl>
+                                          </p:spTgt>
+                                        </p:tgtEl>
+                                        <p:attrNameLst>
+                                          <p:attrName>style.visibility</p:attrName>
+                                        </p:attrNameLst>
+                                      </p:cBhvr>
+                                      <p:to>
+                                        <p:strVal val="visible"/>
+                                      </p:to>
+                                    </p:set>
+                                  </p:childTnLst>
+                                </p:cTn>
+                              </p:par>
+                            </p:childTnLst>
+                          </p:cTn>
+                        </p:par>
+                      </p:childTnLst>
+                    </p:cTn>
+                  </p:par>
+                </p:childTnLst>
+              </p:cTn>
+              <p:prevCondLst>
+                <p:cond evt="onPrev" delay="0">
+                  <p:tgtEl>
+                    <p:sldTgt/>
+                  </p:tgtEl>
+                </p:cond>
+              </p:prevCondLst>
+              <p:nextCondLst>
+                <p:cond evt="onNext" delay="0">
+                  <p:tgtEl>
+                    <p:sldTgt/>
+                  </p:tgtEl>
+                </p:cond>
+              </p:nextCondLst>
+            </p:seq>
+          </p:childTnLst>
+        </p:cTn>
+      </p:par>
+    </p:tnLst>
+  </p:timing>
 </p:sld>
 </file>
 
@@ -26488,6 +27489,428 @@
   <p:clrMapOvr>
     <a:masterClrMapping/>
   </p:clrMapOvr>
+  <p:timing>
+    <p:tnLst>
+      <p:par>
+        <p:cTn id="1" dur="indefinite" restart="never" nodeType="tmRoot">
+          <p:childTnLst>
+            <p:seq concurrent="1" nextAc="seek">
+              <p:cTn id="2" dur="indefinite" nodeType="mainSeq">
+                <p:childTnLst>
+                  <p:par>
+                    <p:cTn id="3" fill="hold">
+                      <p:stCondLst>
+                        <p:cond delay="indefinite"/>
+                      </p:stCondLst>
+                      <p:childTnLst>
+                        <p:par>
+                          <p:cTn id="4" fill="hold">
+                            <p:stCondLst>
+                              <p:cond delay="0"/>
+                            </p:stCondLst>
+                            <p:childTnLst>
+                              <p:par>
+                                <p:cTn id="5" presetID="1" presetClass="entr" presetSubtype="0" fill="hold" nodeType="clickEffect">
+                                  <p:stCondLst>
+                                    <p:cond delay="0"/>
+                                  </p:stCondLst>
+                                  <p:childTnLst>
+                                    <p:set>
+                                      <p:cBhvr>
+                                        <p:cTn id="6" dur="1" fill="hold">
+                                          <p:stCondLst>
+                                            <p:cond delay="0"/>
+                                          </p:stCondLst>
+                                        </p:cTn>
+                                        <p:tgtEl>
+                                          <p:spTgt spid="6">
+                                            <p:txEl>
+                                              <p:pRg st="0" end="0"/>
+                                            </p:txEl>
+                                          </p:spTgt>
+                                        </p:tgtEl>
+                                        <p:attrNameLst>
+                                          <p:attrName>style.visibility</p:attrName>
+                                        </p:attrNameLst>
+                                      </p:cBhvr>
+                                      <p:to>
+                                        <p:strVal val="visible"/>
+                                      </p:to>
+                                    </p:set>
+                                  </p:childTnLst>
+                                </p:cTn>
+                              </p:par>
+                            </p:childTnLst>
+                          </p:cTn>
+                        </p:par>
+                      </p:childTnLst>
+                    </p:cTn>
+                  </p:par>
+                  <p:par>
+                    <p:cTn id="7" fill="hold">
+                      <p:stCondLst>
+                        <p:cond delay="indefinite"/>
+                      </p:stCondLst>
+                      <p:childTnLst>
+                        <p:par>
+                          <p:cTn id="8" fill="hold">
+                            <p:stCondLst>
+                              <p:cond delay="0"/>
+                            </p:stCondLst>
+                            <p:childTnLst>
+                              <p:par>
+                                <p:cTn id="9" presetID="1" presetClass="entr" presetSubtype="0" fill="hold" nodeType="clickEffect">
+                                  <p:stCondLst>
+                                    <p:cond delay="0"/>
+                                  </p:stCondLst>
+                                  <p:childTnLst>
+                                    <p:set>
+                                      <p:cBhvr>
+                                        <p:cTn id="10" dur="1" fill="hold">
+                                          <p:stCondLst>
+                                            <p:cond delay="0"/>
+                                          </p:stCondLst>
+                                        </p:cTn>
+                                        <p:tgtEl>
+                                          <p:spTgt spid="6">
+                                            <p:txEl>
+                                              <p:pRg st="1" end="1"/>
+                                            </p:txEl>
+                                          </p:spTgt>
+                                        </p:tgtEl>
+                                        <p:attrNameLst>
+                                          <p:attrName>style.visibility</p:attrName>
+                                        </p:attrNameLst>
+                                      </p:cBhvr>
+                                      <p:to>
+                                        <p:strVal val="visible"/>
+                                      </p:to>
+                                    </p:set>
+                                  </p:childTnLst>
+                                </p:cTn>
+                              </p:par>
+                            </p:childTnLst>
+                          </p:cTn>
+                        </p:par>
+                      </p:childTnLst>
+                    </p:cTn>
+                  </p:par>
+                  <p:par>
+                    <p:cTn id="11" fill="hold">
+                      <p:stCondLst>
+                        <p:cond delay="indefinite"/>
+                      </p:stCondLst>
+                      <p:childTnLst>
+                        <p:par>
+                          <p:cTn id="12" fill="hold">
+                            <p:stCondLst>
+                              <p:cond delay="0"/>
+                            </p:stCondLst>
+                            <p:childTnLst>
+                              <p:par>
+                                <p:cTn id="13" presetID="1" presetClass="entr" presetSubtype="0" fill="hold" nodeType="clickEffect">
+                                  <p:stCondLst>
+                                    <p:cond delay="0"/>
+                                  </p:stCondLst>
+                                  <p:childTnLst>
+                                    <p:set>
+                                      <p:cBhvr>
+                                        <p:cTn id="14" dur="1" fill="hold">
+                                          <p:stCondLst>
+                                            <p:cond delay="0"/>
+                                          </p:stCondLst>
+                                        </p:cTn>
+                                        <p:tgtEl>
+                                          <p:spTgt spid="6">
+                                            <p:txEl>
+                                              <p:pRg st="2" end="2"/>
+                                            </p:txEl>
+                                          </p:spTgt>
+                                        </p:tgtEl>
+                                        <p:attrNameLst>
+                                          <p:attrName>style.visibility</p:attrName>
+                                        </p:attrNameLst>
+                                      </p:cBhvr>
+                                      <p:to>
+                                        <p:strVal val="visible"/>
+                                      </p:to>
+                                    </p:set>
+                                  </p:childTnLst>
+                                </p:cTn>
+                              </p:par>
+                            </p:childTnLst>
+                          </p:cTn>
+                        </p:par>
+                      </p:childTnLst>
+                    </p:cTn>
+                  </p:par>
+                  <p:par>
+                    <p:cTn id="15" fill="hold">
+                      <p:stCondLst>
+                        <p:cond delay="indefinite"/>
+                      </p:stCondLst>
+                      <p:childTnLst>
+                        <p:par>
+                          <p:cTn id="16" fill="hold">
+                            <p:stCondLst>
+                              <p:cond delay="0"/>
+                            </p:stCondLst>
+                            <p:childTnLst>
+                              <p:par>
+                                <p:cTn id="17" presetID="1" presetClass="entr" presetSubtype="0" fill="hold" nodeType="clickEffect">
+                                  <p:stCondLst>
+                                    <p:cond delay="0"/>
+                                  </p:stCondLst>
+                                  <p:childTnLst>
+                                    <p:set>
+                                      <p:cBhvr>
+                                        <p:cTn id="18" dur="1" fill="hold">
+                                          <p:stCondLst>
+                                            <p:cond delay="0"/>
+                                          </p:stCondLst>
+                                        </p:cTn>
+                                        <p:tgtEl>
+                                          <p:spTgt spid="6">
+                                            <p:txEl>
+                                              <p:pRg st="3" end="3"/>
+                                            </p:txEl>
+                                          </p:spTgt>
+                                        </p:tgtEl>
+                                        <p:attrNameLst>
+                                          <p:attrName>style.visibility</p:attrName>
+                                        </p:attrNameLst>
+                                      </p:cBhvr>
+                                      <p:to>
+                                        <p:strVal val="visible"/>
+                                      </p:to>
+                                    </p:set>
+                                  </p:childTnLst>
+                                </p:cTn>
+                              </p:par>
+                            </p:childTnLst>
+                          </p:cTn>
+                        </p:par>
+                      </p:childTnLst>
+                    </p:cTn>
+                  </p:par>
+                  <p:par>
+                    <p:cTn id="19" fill="hold">
+                      <p:stCondLst>
+                        <p:cond delay="indefinite"/>
+                      </p:stCondLst>
+                      <p:childTnLst>
+                        <p:par>
+                          <p:cTn id="20" fill="hold">
+                            <p:stCondLst>
+                              <p:cond delay="0"/>
+                            </p:stCondLst>
+                            <p:childTnLst>
+                              <p:par>
+                                <p:cTn id="21" presetID="1" presetClass="entr" presetSubtype="0" fill="hold" nodeType="clickEffect">
+                                  <p:stCondLst>
+                                    <p:cond delay="0"/>
+                                  </p:stCondLst>
+                                  <p:childTnLst>
+                                    <p:set>
+                                      <p:cBhvr>
+                                        <p:cTn id="22" dur="1" fill="hold">
+                                          <p:stCondLst>
+                                            <p:cond delay="0"/>
+                                          </p:stCondLst>
+                                        </p:cTn>
+                                        <p:tgtEl>
+                                          <p:spTgt spid="6">
+                                            <p:txEl>
+                                              <p:pRg st="4" end="4"/>
+                                            </p:txEl>
+                                          </p:spTgt>
+                                        </p:tgtEl>
+                                        <p:attrNameLst>
+                                          <p:attrName>style.visibility</p:attrName>
+                                        </p:attrNameLst>
+                                      </p:cBhvr>
+                                      <p:to>
+                                        <p:strVal val="visible"/>
+                                      </p:to>
+                                    </p:set>
+                                  </p:childTnLst>
+                                </p:cTn>
+                              </p:par>
+                            </p:childTnLst>
+                          </p:cTn>
+                        </p:par>
+                      </p:childTnLst>
+                    </p:cTn>
+                  </p:par>
+                  <p:par>
+                    <p:cTn id="23" fill="hold">
+                      <p:stCondLst>
+                        <p:cond delay="indefinite"/>
+                      </p:stCondLst>
+                      <p:childTnLst>
+                        <p:par>
+                          <p:cTn id="24" fill="hold">
+                            <p:stCondLst>
+                              <p:cond delay="0"/>
+                            </p:stCondLst>
+                            <p:childTnLst>
+                              <p:par>
+                                <p:cTn id="25" presetID="1" presetClass="entr" presetSubtype="0" fill="hold" nodeType="clickEffect">
+                                  <p:stCondLst>
+                                    <p:cond delay="0"/>
+                                  </p:stCondLst>
+                                  <p:childTnLst>
+                                    <p:set>
+                                      <p:cBhvr>
+                                        <p:cTn id="26" dur="1" fill="hold">
+                                          <p:stCondLst>
+                                            <p:cond delay="0"/>
+                                          </p:stCondLst>
+                                        </p:cTn>
+                                        <p:tgtEl>
+                                          <p:spTgt spid="6">
+                                            <p:txEl>
+                                              <p:pRg st="5" end="5"/>
+                                            </p:txEl>
+                                          </p:spTgt>
+                                        </p:tgtEl>
+                                        <p:attrNameLst>
+                                          <p:attrName>style.visibility</p:attrName>
+                                        </p:attrNameLst>
+                                      </p:cBhvr>
+                                      <p:to>
+                                        <p:strVal val="visible"/>
+                                      </p:to>
+                                    </p:set>
+                                  </p:childTnLst>
+                                </p:cTn>
+                              </p:par>
+                            </p:childTnLst>
+                          </p:cTn>
+                        </p:par>
+                      </p:childTnLst>
+                    </p:cTn>
+                  </p:par>
+                  <p:par>
+                    <p:cTn id="27" fill="hold">
+                      <p:stCondLst>
+                        <p:cond delay="indefinite"/>
+                      </p:stCondLst>
+                      <p:childTnLst>
+                        <p:par>
+                          <p:cTn id="28" fill="hold">
+                            <p:stCondLst>
+                              <p:cond delay="0"/>
+                            </p:stCondLst>
+                            <p:childTnLst>
+                              <p:par>
+                                <p:cTn id="29" presetID="1" presetClass="entr" presetSubtype="0" fill="hold" nodeType="clickEffect">
+                                  <p:stCondLst>
+                                    <p:cond delay="0"/>
+                                  </p:stCondLst>
+                                  <p:childTnLst>
+                                    <p:set>
+                                      <p:cBhvr>
+                                        <p:cTn id="30" dur="1" fill="hold">
+                                          <p:stCondLst>
+                                            <p:cond delay="0"/>
+                                          </p:stCondLst>
+                                        </p:cTn>
+                                        <p:tgtEl>
+                                          <p:spTgt spid="6">
+                                            <p:txEl>
+                                              <p:pRg st="6" end="6"/>
+                                            </p:txEl>
+                                          </p:spTgt>
+                                        </p:tgtEl>
+                                        <p:attrNameLst>
+                                          <p:attrName>style.visibility</p:attrName>
+                                        </p:attrNameLst>
+                                      </p:cBhvr>
+                                      <p:to>
+                                        <p:strVal val="visible"/>
+                                      </p:to>
+                                    </p:set>
+                                  </p:childTnLst>
+                                </p:cTn>
+                              </p:par>
+                            </p:childTnLst>
+                          </p:cTn>
+                        </p:par>
+                      </p:childTnLst>
+                    </p:cTn>
+                  </p:par>
+                  <p:par>
+                    <p:cTn id="31" fill="hold">
+                      <p:stCondLst>
+                        <p:cond delay="indefinite"/>
+                      </p:stCondLst>
+                      <p:childTnLst>
+                        <p:par>
+                          <p:cTn id="32" fill="hold">
+                            <p:stCondLst>
+                              <p:cond delay="0"/>
+                            </p:stCondLst>
+                            <p:childTnLst>
+                              <p:par>
+                                <p:cTn id="33" presetID="1" presetClass="entr" presetSubtype="0" fill="hold" nodeType="clickEffect">
+                                  <p:stCondLst>
+                                    <p:cond delay="0"/>
+                                  </p:stCondLst>
+                                  <p:childTnLst>
+                                    <p:set>
+                                      <p:cBhvr>
+                                        <p:cTn id="34" dur="1" fill="hold">
+                                          <p:stCondLst>
+                                            <p:cond delay="0"/>
+                                          </p:stCondLst>
+                                        </p:cTn>
+                                        <p:tgtEl>
+                                          <p:spTgt spid="6">
+                                            <p:txEl>
+                                              <p:pRg st="7" end="7"/>
+                                            </p:txEl>
+                                          </p:spTgt>
+                                        </p:tgtEl>
+                                        <p:attrNameLst>
+                                          <p:attrName>style.visibility</p:attrName>
+                                        </p:attrNameLst>
+                                      </p:cBhvr>
+                                      <p:to>
+                                        <p:strVal val="visible"/>
+                                      </p:to>
+                                    </p:set>
+                                  </p:childTnLst>
+                                </p:cTn>
+                              </p:par>
+                            </p:childTnLst>
+                          </p:cTn>
+                        </p:par>
+                      </p:childTnLst>
+                    </p:cTn>
+                  </p:par>
+                </p:childTnLst>
+              </p:cTn>
+              <p:prevCondLst>
+                <p:cond evt="onPrev" delay="0">
+                  <p:tgtEl>
+                    <p:sldTgt/>
+                  </p:tgtEl>
+                </p:cond>
+              </p:prevCondLst>
+              <p:nextCondLst>
+                <p:cond evt="onNext" delay="0">
+                  <p:tgtEl>
+                    <p:sldTgt/>
+                  </p:tgtEl>
+                </p:cond>
+              </p:nextCondLst>
+            </p:seq>
+          </p:childTnLst>
+        </p:cTn>
+      </p:par>
+    </p:tnLst>
+  </p:timing>
 </p:sld>
 </file>
 
@@ -26544,7 +27967,9 @@
         </p:nvSpPr>
         <p:spPr/>
         <p:txBody>
-          <a:bodyPr/>
+          <a:bodyPr>
+            <a:normAutofit fontScale="85000" lnSpcReduction="20000"/>
+          </a:bodyPr>
           <a:lstStyle/>
           <a:p>
             <a:pPr marL="0" lvl="0" indent="0">
@@ -26575,7 +28000,7 @@
             </a:r>
             <a:r>
               <a:rPr lang="en-US" dirty="0"/>
-              <a:t> using independent prior for each category</a:t>
+              <a:t> using independent prior for each category or strata</a:t>
             </a:r>
           </a:p>
           <a:p>
@@ -26590,14 +28015,14 @@
             </a:r>
             <a:r>
               <a:rPr lang="en-US" dirty="0"/>
-              <a:t> of observations within each category</a:t>
+              <a:t> of observations within each strata</a:t>
             </a:r>
           </a:p>
           <a:p>
             <a:pPr lvl="1"/>
             <a:r>
               <a:rPr lang="en-US" dirty="0"/>
-              <a:t>No exchangeability between categories  </a:t>
+              <a:t>No exchangeability between strata </a:t>
             </a:r>
             <a:endParaRPr dirty="0"/>
           </a:p>
@@ -26614,6 +28039,20 @@
               <a:rPr lang="en-US" dirty="0"/>
               <a:t>Leads to posterior distributions with wide dispersion </a:t>
             </a:r>
+          </a:p>
+          <a:p>
+            <a:pPr lvl="1"/>
+            <a:r>
+              <a:rPr lang="en-US" dirty="0"/>
+              <a:t>Large number of parameters</a:t>
+            </a:r>
+          </a:p>
+          <a:p>
+            <a:pPr lvl="1"/>
+            <a:r>
+              <a:rPr lang="en-US" dirty="0"/>
+              <a:t>Data per parameter is limited</a:t>
+            </a:r>
             <a:endParaRPr dirty="0"/>
           </a:p>
           <a:p>
@@ -26624,16 +28063,28 @@
             </a:r>
             <a:r>
               <a:rPr dirty="0"/>
-              <a:t> models ha</a:t>
+              <a:t> mode</a:t>
             </a:r>
             <a:r>
               <a:rPr lang="en-US" dirty="0"/>
-              <a:t>ve</a:t>
+              <a:t> are comprised of a </a:t>
             </a:r>
             <a:r>
               <a:rPr dirty="0"/>
-              <a:t> a flat structure</a:t>
-            </a:r>
+              <a:t>flat structure</a:t>
+            </a:r>
+            <a:r>
+              <a:rPr lang="en-US" dirty="0"/>
+              <a:t> model for each strata</a:t>
+            </a:r>
+          </a:p>
+          <a:p>
+            <a:pPr lvl="1"/>
+            <a:r>
+              <a:rPr lang="en-US" dirty="0"/>
+              <a:t>Common prior for all strata</a:t>
+            </a:r>
+            <a:endParaRPr dirty="0"/>
           </a:p>
         </p:txBody>
       </p:sp>
@@ -26853,26 +28304,39 @@
                                   </p:childTnLst>
                                 </p:cTn>
                               </p:par>
-                            </p:childTnLst>
-                          </p:cTn>
-                        </p:par>
-                      </p:childTnLst>
-                    </p:cTn>
-                  </p:par>
-                  <p:par>
-                    <p:cTn id="19" fill="hold">
-                      <p:stCondLst>
-                        <p:cond delay="indefinite"/>
-                      </p:stCondLst>
-                      <p:childTnLst>
-                        <p:par>
-                          <p:cTn id="20" fill="hold">
-                            <p:stCondLst>
-                              <p:cond delay="0"/>
-                            </p:stCondLst>
-                            <p:childTnLst>
                               <p:par>
-                                <p:cTn id="21" presetID="1" presetClass="entr" presetSubtype="0" fill="hold" nodeType="clickEffect">
+                                <p:cTn id="19" presetID="1" presetClass="entr" presetSubtype="0" fill="hold" nodeType="withEffect">
+                                  <p:stCondLst>
+                                    <p:cond delay="0"/>
+                                  </p:stCondLst>
+                                  <p:childTnLst>
+                                    <p:set>
+                                      <p:cBhvr>
+                                        <p:cTn id="20" dur="1" fill="hold">
+                                          <p:stCondLst>
+                                            <p:cond delay="0"/>
+                                          </p:stCondLst>
+                                        </p:cTn>
+                                        <p:tgtEl>
+                                          <p:spTgt spid="3">
+                                            <p:txEl>
+                                              <p:pRg st="6" end="6"/>
+                                            </p:txEl>
+                                          </p:spTgt>
+                                        </p:tgtEl>
+                                        <p:attrNameLst>
+                                          <p:attrName>style.visibility</p:attrName>
+                                        </p:attrNameLst>
+                                      </p:cBhvr>
+                                      <p:to>
+                                        <p:strVal val="visible"/>
+                                      </p:to>
+                                    </p:set>
+                                  </p:childTnLst>
+                                </p:cTn>
+                              </p:par>
+                              <p:par>
+                                <p:cTn id="21" presetID="1" presetClass="entr" presetSubtype="0" fill="hold" nodeType="withEffect">
                                   <p:stCondLst>
                                     <p:cond delay="0"/>
                                   </p:stCondLst>
@@ -26887,7 +28351,87 @@
                                         <p:tgtEl>
                                           <p:spTgt spid="3">
                                             <p:txEl>
-                                              <p:pRg st="6" end="6"/>
+                                              <p:pRg st="7" end="7"/>
+                                            </p:txEl>
+                                          </p:spTgt>
+                                        </p:tgtEl>
+                                        <p:attrNameLst>
+                                          <p:attrName>style.visibility</p:attrName>
+                                        </p:attrNameLst>
+                                      </p:cBhvr>
+                                      <p:to>
+                                        <p:strVal val="visible"/>
+                                      </p:to>
+                                    </p:set>
+                                  </p:childTnLst>
+                                </p:cTn>
+                              </p:par>
+                            </p:childTnLst>
+                          </p:cTn>
+                        </p:par>
+                      </p:childTnLst>
+                    </p:cTn>
+                  </p:par>
+                  <p:par>
+                    <p:cTn id="23" fill="hold">
+                      <p:stCondLst>
+                        <p:cond delay="indefinite"/>
+                      </p:stCondLst>
+                      <p:childTnLst>
+                        <p:par>
+                          <p:cTn id="24" fill="hold">
+                            <p:stCondLst>
+                              <p:cond delay="0"/>
+                            </p:stCondLst>
+                            <p:childTnLst>
+                              <p:par>
+                                <p:cTn id="25" presetID="1" presetClass="entr" presetSubtype="0" fill="hold" nodeType="clickEffect">
+                                  <p:stCondLst>
+                                    <p:cond delay="0"/>
+                                  </p:stCondLst>
+                                  <p:childTnLst>
+                                    <p:set>
+                                      <p:cBhvr>
+                                        <p:cTn id="26" dur="1" fill="hold">
+                                          <p:stCondLst>
+                                            <p:cond delay="0"/>
+                                          </p:stCondLst>
+                                        </p:cTn>
+                                        <p:tgtEl>
+                                          <p:spTgt spid="3">
+                                            <p:txEl>
+                                              <p:pRg st="8" end="8"/>
+                                            </p:txEl>
+                                          </p:spTgt>
+                                        </p:tgtEl>
+                                        <p:attrNameLst>
+                                          <p:attrName>style.visibility</p:attrName>
+                                        </p:attrNameLst>
+                                      </p:cBhvr>
+                                      <p:to>
+                                        <p:strVal val="visible"/>
+                                      </p:to>
+                                    </p:set>
+                                  </p:childTnLst>
+                                </p:cTn>
+                              </p:par>
+                              <p:par>
+                                <p:cTn id="27" presetID="1" presetClass="entr" presetSubtype="0" fill="hold" nodeType="withEffect">
+                                  <p:stCondLst>
+                                    <p:cond delay="0"/>
+                                  </p:stCondLst>
+                                  <p:childTnLst>
+                                    <p:set>
+                                      <p:cBhvr>
+                                        <p:cTn id="28" dur="1" fill="hold">
+                                          <p:stCondLst>
+                                            <p:cond delay="0"/>
+                                          </p:stCondLst>
+                                        </p:cTn>
+                                        <p:tgtEl>
+                                          <p:spTgt spid="3">
+                                            <p:txEl>
+                                              <p:pRg st="9" end="9"/>
                                             </p:txEl>
                                           </p:spTgt>
                                         </p:tgtEl>
@@ -27280,6 +28824,259 @@
   <p:clrMapOvr>
     <a:masterClrMapping/>
   </p:clrMapOvr>
+  <p:timing>
+    <p:tnLst>
+      <p:par>
+        <p:cTn id="1" dur="indefinite" restart="never" nodeType="tmRoot">
+          <p:childTnLst>
+            <p:seq concurrent="1" nextAc="seek">
+              <p:cTn id="2" dur="indefinite" nodeType="mainSeq">
+                <p:childTnLst>
+                  <p:par>
+                    <p:cTn id="3" fill="hold">
+                      <p:stCondLst>
+                        <p:cond delay="indefinite"/>
+                      </p:stCondLst>
+                      <p:childTnLst>
+                        <p:par>
+                          <p:cTn id="4" fill="hold">
+                            <p:stCondLst>
+                              <p:cond delay="0"/>
+                            </p:stCondLst>
+                            <p:childTnLst>
+                              <p:par>
+                                <p:cTn id="5" presetID="1" presetClass="entr" presetSubtype="0" fill="hold" nodeType="clickEffect">
+                                  <p:stCondLst>
+                                    <p:cond delay="0"/>
+                                  </p:stCondLst>
+                                  <p:childTnLst>
+                                    <p:set>
+                                      <p:cBhvr>
+                                        <p:cTn id="6" dur="1" fill="hold">
+                                          <p:stCondLst>
+                                            <p:cond delay="0"/>
+                                          </p:stCondLst>
+                                        </p:cTn>
+                                        <p:tgtEl>
+                                          <p:spTgt spid="6">
+                                            <p:txEl>
+                                              <p:pRg st="0" end="0"/>
+                                            </p:txEl>
+                                          </p:spTgt>
+                                        </p:tgtEl>
+                                        <p:attrNameLst>
+                                          <p:attrName>style.visibility</p:attrName>
+                                        </p:attrNameLst>
+                                      </p:cBhvr>
+                                      <p:to>
+                                        <p:strVal val="visible"/>
+                                      </p:to>
+                                    </p:set>
+                                  </p:childTnLst>
+                                </p:cTn>
+                              </p:par>
+                              <p:par>
+                                <p:cTn id="7" presetID="1" presetClass="entr" presetSubtype="0" fill="hold" nodeType="withEffect">
+                                  <p:stCondLst>
+                                    <p:cond delay="0"/>
+                                  </p:stCondLst>
+                                  <p:childTnLst>
+                                    <p:set>
+                                      <p:cBhvr>
+                                        <p:cTn id="8" dur="1" fill="hold">
+                                          <p:stCondLst>
+                                            <p:cond delay="0"/>
+                                          </p:stCondLst>
+                                        </p:cTn>
+                                        <p:tgtEl>
+                                          <p:spTgt spid="7"/>
+                                        </p:tgtEl>
+                                        <p:attrNameLst>
+                                          <p:attrName>style.visibility</p:attrName>
+                                        </p:attrNameLst>
+                                      </p:cBhvr>
+                                      <p:to>
+                                        <p:strVal val="visible"/>
+                                      </p:to>
+                                    </p:set>
+                                  </p:childTnLst>
+                                </p:cTn>
+                              </p:par>
+                            </p:childTnLst>
+                          </p:cTn>
+                        </p:par>
+                      </p:childTnLst>
+                    </p:cTn>
+                  </p:par>
+                  <p:par>
+                    <p:cTn id="9" fill="hold">
+                      <p:stCondLst>
+                        <p:cond delay="indefinite"/>
+                      </p:stCondLst>
+                      <p:childTnLst>
+                        <p:par>
+                          <p:cTn id="10" fill="hold">
+                            <p:stCondLst>
+                              <p:cond delay="0"/>
+                            </p:stCondLst>
+                            <p:childTnLst>
+                              <p:par>
+                                <p:cTn id="11" presetID="1" presetClass="entr" presetSubtype="0" fill="hold" nodeType="clickEffect">
+                                  <p:stCondLst>
+                                    <p:cond delay="0"/>
+                                  </p:stCondLst>
+                                  <p:childTnLst>
+                                    <p:set>
+                                      <p:cBhvr>
+                                        <p:cTn id="12" dur="1" fill="hold">
+                                          <p:stCondLst>
+                                            <p:cond delay="0"/>
+                                          </p:stCondLst>
+                                        </p:cTn>
+                                        <p:tgtEl>
+                                          <p:spTgt spid="6">
+                                            <p:txEl>
+                                              <p:pRg st="1" end="1"/>
+                                            </p:txEl>
+                                          </p:spTgt>
+                                        </p:tgtEl>
+                                        <p:attrNameLst>
+                                          <p:attrName>style.visibility</p:attrName>
+                                        </p:attrNameLst>
+                                      </p:cBhvr>
+                                      <p:to>
+                                        <p:strVal val="visible"/>
+                                      </p:to>
+                                    </p:set>
+                                  </p:childTnLst>
+                                </p:cTn>
+                              </p:par>
+                            </p:childTnLst>
+                          </p:cTn>
+                        </p:par>
+                      </p:childTnLst>
+                    </p:cTn>
+                  </p:par>
+                  <p:par>
+                    <p:cTn id="13" fill="hold">
+                      <p:stCondLst>
+                        <p:cond delay="indefinite"/>
+                      </p:stCondLst>
+                      <p:childTnLst>
+                        <p:par>
+                          <p:cTn id="14" fill="hold">
+                            <p:stCondLst>
+                              <p:cond delay="0"/>
+                            </p:stCondLst>
+                            <p:childTnLst>
+                              <p:par>
+                                <p:cTn id="15" presetID="1" presetClass="entr" presetSubtype="0" fill="hold" nodeType="clickEffect">
+                                  <p:stCondLst>
+                                    <p:cond delay="0"/>
+                                  </p:stCondLst>
+                                  <p:childTnLst>
+                                    <p:set>
+                                      <p:cBhvr>
+                                        <p:cTn id="16" dur="1" fill="hold">
+                                          <p:stCondLst>
+                                            <p:cond delay="0"/>
+                                          </p:stCondLst>
+                                        </p:cTn>
+                                        <p:tgtEl>
+                                          <p:spTgt spid="6">
+                                            <p:txEl>
+                                              <p:pRg st="2" end="2"/>
+                                            </p:txEl>
+                                          </p:spTgt>
+                                        </p:tgtEl>
+                                        <p:attrNameLst>
+                                          <p:attrName>style.visibility</p:attrName>
+                                        </p:attrNameLst>
+                                      </p:cBhvr>
+                                      <p:to>
+                                        <p:strVal val="visible"/>
+                                      </p:to>
+                                    </p:set>
+                                  </p:childTnLst>
+                                </p:cTn>
+                              </p:par>
+                            </p:childTnLst>
+                          </p:cTn>
+                        </p:par>
+                      </p:childTnLst>
+                    </p:cTn>
+                  </p:par>
+                  <p:par>
+                    <p:cTn id="17" fill="hold">
+                      <p:stCondLst>
+                        <p:cond delay="indefinite"/>
+                      </p:stCondLst>
+                      <p:childTnLst>
+                        <p:par>
+                          <p:cTn id="18" fill="hold">
+                            <p:stCondLst>
+                              <p:cond delay="0"/>
+                            </p:stCondLst>
+                            <p:childTnLst>
+                              <p:par>
+                                <p:cTn id="19" presetID="1" presetClass="entr" presetSubtype="0" fill="hold" nodeType="clickEffect">
+                                  <p:stCondLst>
+                                    <p:cond delay="0"/>
+                                  </p:stCondLst>
+                                  <p:childTnLst>
+                                    <p:set>
+                                      <p:cBhvr>
+                                        <p:cTn id="20" dur="1" fill="hold">
+                                          <p:stCondLst>
+                                            <p:cond delay="0"/>
+                                          </p:stCondLst>
+                                        </p:cTn>
+                                        <p:tgtEl>
+                                          <p:spTgt spid="6">
+                                            <p:txEl>
+                                              <p:pRg st="3" end="3"/>
+                                            </p:txEl>
+                                          </p:spTgt>
+                                        </p:tgtEl>
+                                        <p:attrNameLst>
+                                          <p:attrName>style.visibility</p:attrName>
+                                        </p:attrNameLst>
+                                      </p:cBhvr>
+                                      <p:to>
+                                        <p:strVal val="visible"/>
+                                      </p:to>
+                                    </p:set>
+                                  </p:childTnLst>
+                                </p:cTn>
+                              </p:par>
+                            </p:childTnLst>
+                          </p:cTn>
+                        </p:par>
+                      </p:childTnLst>
+                    </p:cTn>
+                  </p:par>
+                </p:childTnLst>
+              </p:cTn>
+              <p:prevCondLst>
+                <p:cond evt="onPrev" delay="0">
+                  <p:tgtEl>
+                    <p:sldTgt/>
+                  </p:tgtEl>
+                </p:cond>
+              </p:prevCondLst>
+              <p:nextCondLst>
+                <p:cond evt="onNext" delay="0">
+                  <p:tgtEl>
+                    <p:sldTgt/>
+                  </p:tgtEl>
+                </p:cond>
+              </p:nextCondLst>
+            </p:seq>
+          </p:childTnLst>
+        </p:cTn>
+      </p:par>
+    </p:tnLst>
+  </p:timing>
 </p:sld>
 </file>
 
@@ -28876,6 +30673,33 @@
                                   </p:childTnLst>
                                 </p:cTn>
                               </p:par>
+                              <p:par>
+                                <p:cTn id="7" presetID="1" presetClass="entr" presetSubtype="0" fill="hold" nodeType="withEffect">
+                                  <p:stCondLst>
+                                    <p:cond delay="0"/>
+                                  </p:stCondLst>
+                                  <p:childTnLst>
+                                    <p:set>
+                                      <p:cBhvr>
+                                        <p:cTn id="8" dur="1" fill="hold">
+                                          <p:stCondLst>
+                                            <p:cond delay="0"/>
+                                          </p:stCondLst>
+                                        </p:cTn>
+                                        <p:tgtEl>
+                                          <p:spTgt spid="5"/>
+                                        </p:tgtEl>
+                                        <p:attrNameLst>
+                                          <p:attrName>style.visibility</p:attrName>
+                                        </p:attrNameLst>
+                                      </p:cBhvr>
+                                      <p:to>
+                                        <p:strVal val="visible"/>
+                                      </p:to>
+                                    </p:set>
+                                  </p:childTnLst>
+                                </p:cTn>
+                              </p:par>
                             </p:childTnLst>
                           </p:cTn>
                         </p:par>
@@ -28883,26 +30707,26 @@
                     </p:cTn>
                   </p:par>
                   <p:par>
-                    <p:cTn id="7" fill="hold">
+                    <p:cTn id="9" fill="hold">
                       <p:stCondLst>
                         <p:cond delay="indefinite"/>
                       </p:stCondLst>
                       <p:childTnLst>
                         <p:par>
-                          <p:cTn id="8" fill="hold">
+                          <p:cTn id="10" fill="hold">
                             <p:stCondLst>
                               <p:cond delay="0"/>
                             </p:stCondLst>
                             <p:childTnLst>
                               <p:par>
-                                <p:cTn id="9" presetID="1" presetClass="entr" presetSubtype="0" fill="hold" nodeType="clickEffect">
+                                <p:cTn id="11" presetID="1" presetClass="entr" presetSubtype="0" fill="hold" nodeType="clickEffect">
                                   <p:stCondLst>
                                     <p:cond delay="0"/>
                                   </p:stCondLst>
                                   <p:childTnLst>
                                     <p:set>
                                       <p:cBhvr>
-                                        <p:cTn id="10" dur="1" fill="hold">
+                                        <p:cTn id="12" dur="1" fill="hold">
                                           <p:stCondLst>
                                             <p:cond delay="0"/>
                                           </p:stCondLst>
@@ -28932,26 +30756,26 @@
                     </p:cTn>
                   </p:par>
                   <p:par>
-                    <p:cTn id="11" fill="hold">
+                    <p:cTn id="13" fill="hold">
                       <p:stCondLst>
                         <p:cond delay="indefinite"/>
                       </p:stCondLst>
                       <p:childTnLst>
                         <p:par>
-                          <p:cTn id="12" fill="hold">
+                          <p:cTn id="14" fill="hold">
                             <p:stCondLst>
                               <p:cond delay="0"/>
                             </p:stCondLst>
                             <p:childTnLst>
                               <p:par>
-                                <p:cTn id="13" presetID="1" presetClass="entr" presetSubtype="0" fill="hold" nodeType="clickEffect">
+                                <p:cTn id="15" presetID="1" presetClass="entr" presetSubtype="0" fill="hold" nodeType="clickEffect">
                                   <p:stCondLst>
                                     <p:cond delay="0"/>
                                   </p:stCondLst>
                                   <p:childTnLst>
                                     <p:set>
                                       <p:cBhvr>
-                                        <p:cTn id="14" dur="1" fill="hold">
+                                        <p:cTn id="16" dur="1" fill="hold">
                                           <p:stCondLst>
                                             <p:cond delay="0"/>
                                           </p:stCondLst>
@@ -28981,26 +30805,26 @@
                     </p:cTn>
                   </p:par>
                   <p:par>
-                    <p:cTn id="15" fill="hold">
+                    <p:cTn id="17" fill="hold">
                       <p:stCondLst>
                         <p:cond delay="indefinite"/>
                       </p:stCondLst>
                       <p:childTnLst>
                         <p:par>
-                          <p:cTn id="16" fill="hold">
+                          <p:cTn id="18" fill="hold">
                             <p:stCondLst>
                               <p:cond delay="0"/>
                             </p:stCondLst>
                             <p:childTnLst>
                               <p:par>
-                                <p:cTn id="17" presetID="1" presetClass="entr" presetSubtype="0" fill="hold" nodeType="clickEffect">
+                                <p:cTn id="19" presetID="1" presetClass="entr" presetSubtype="0" fill="hold" nodeType="clickEffect">
                                   <p:stCondLst>
                                     <p:cond delay="0"/>
                                   </p:stCondLst>
                                   <p:childTnLst>
                                     <p:set>
                                       <p:cBhvr>
-                                        <p:cTn id="18" dur="1" fill="hold">
+                                        <p:cTn id="20" dur="1" fill="hold">
                                           <p:stCondLst>
                                             <p:cond delay="0"/>
                                           </p:stCondLst>
@@ -30103,7 +31927,7 @@
         <p:spPr/>
         <p:txBody>
           <a:bodyPr>
-            <a:normAutofit fontScale="92500" lnSpcReduction="20000"/>
+            <a:normAutofit fontScale="85000" lnSpcReduction="10000"/>
           </a:bodyPr>
           <a:lstStyle/>
           <a:p>
@@ -30187,9 +32011,15 @@
             </a:r>
             <a:r>
               <a:rPr lang="en-US" dirty="0"/>
-              <a:t>of observations within each strata for priors and posteriors</a:t>
-            </a:r>
-            <a:endParaRPr dirty="0"/>
+              <a:t>of observations within each strata for priors and posterior</a:t>
+            </a:r>
+          </a:p>
+          <a:p>
+            <a:pPr lvl="1"/>
+            <a:r>
+              <a:rPr lang="en-US" dirty="0"/>
+              <a:t>No exchangeability between strata</a:t>
+            </a:r>
           </a:p>
         </p:txBody>
       </p:sp>
@@ -30431,6 +32261,37 @@
                                           <p:spTgt spid="3">
                                             <p:txEl>
                                               <p:pRg st="5" end="5"/>
+                                            </p:txEl>
+                                          </p:spTgt>
+                                        </p:tgtEl>
+                                        <p:attrNameLst>
+                                          <p:attrName>style.visibility</p:attrName>
+                                        </p:attrNameLst>
+                                      </p:cBhvr>
+                                      <p:to>
+                                        <p:strVal val="visible"/>
+                                      </p:to>
+                                    </p:set>
+                                  </p:childTnLst>
+                                </p:cTn>
+                              </p:par>
+                              <p:par>
+                                <p:cTn id="23" presetID="1" presetClass="entr" presetSubtype="0" fill="hold" nodeType="withEffect">
+                                  <p:stCondLst>
+                                    <p:cond delay="0"/>
+                                  </p:stCondLst>
+                                  <p:childTnLst>
+                                    <p:set>
+                                      <p:cBhvr>
+                                        <p:cTn id="24" dur="1" fill="hold">
+                                          <p:stCondLst>
+                                            <p:cond delay="0"/>
+                                          </p:stCondLst>
+                                        </p:cTn>
+                                        <p:tgtEl>
+                                          <p:spTgt spid="3">
+                                            <p:txEl>
+                                              <p:pRg st="6" end="6"/>
                                             </p:txEl>
                                           </p:spTgt>
                                         </p:tgtEl>

</xml_diff>